<commit_message>
Personalize project files and sync repo
</commit_message>
<xml_diff>
--- a/Steganography Project.pptx
+++ b/Steganography Project.pptx
@@ -1,5 +1,1722 @@
 
-<file path=ppt/presentation.xml><?xml version="1.0" encoding="utf-8"?>
+<file path=ppt\notesMasters\notesMaster1.xml><?xml version="1.0" encoding="utf-8"?>
+<p:notesMaster xmlns:a="http://schemas.openxmlformats.org/drawingml/2006/main" xmlns:r="http://schemas.openxmlformats.org/officeDocument/2006/relationships" xmlns:mc="http://schemas.openxmlformats.org/markup-compatibility/2006" xmlns:mv="urn:schemas-microsoft-com:mac:vml" xmlns:p="http://schemas.openxmlformats.org/presentationml/2006/main" xmlns:c="http://schemas.openxmlformats.org/drawingml/2006/chart" xmlns:dgm="http://schemas.openxmlformats.org/drawingml/2006/diagram" xmlns:o="urn:schemas-microsoft-com:office:office" xmlns:v="urn:schemas-microsoft-com:vml" xmlns:pvml="urn:schemas-microsoft-com:office:powerpoint" xmlns:com="http://schemas.openxmlformats.org/drawingml/2006/compatibility" xmlns:p14="http://schemas.microsoft.com/office/powerpoint/2010/main" xmlns:p15="http://schemas.microsoft.com/office/powerpoint/2012/main" xmlns:ahyp="http://schemas.microsoft.com/office/drawing/2018/hyperlinkcolor">
+  <p:cSld>
+    <p:spTree>
+      <p:nvGrpSpPr>
+        <p:cNvPr id="2" name="Shape 2"/>
+        <p:cNvGrpSpPr/>
+        <p:nvPr/>
+      </p:nvGrpSpPr>
+      <p:grpSpPr>
+        <a:xfrm>
+          <a:off x="0" y="0"/>
+          <a:ext cx="0" cy="0"/>
+          <a:chOff x="0" y="0"/>
+          <a:chExt cx="0" cy="0"/>
+        </a:xfrm>
+      </p:grpSpPr>
+      <p:sp>
+        <p:nvSpPr>
+          <p:cNvPr id="3" name="Google Shape;3;n"/>
+          <p:cNvSpPr/>
+          <p:nvPr>
+            <p:ph idx="2" type="sldImg"/>
+          </p:nvPr>
+        </p:nvSpPr>
+        <p:spPr>
+          <a:xfrm>
+            <a:off x="381300" y="685800"/>
+            <a:ext cx="6096075" cy="3429000"/>
+          </a:xfrm>
+          <a:custGeom>
+            <a:rect b="b" l="l" r="r" t="t"/>
+            <a:pathLst>
+              <a:path extrusionOk="0" h="120000" w="120000">
+                <a:moveTo>
+                  <a:pt x="0" y="0"/>
+                </a:moveTo>
+                <a:lnTo>
+                  <a:pt x="120000" y="0"/>
+                </a:lnTo>
+                <a:lnTo>
+                  <a:pt x="120000" y="120000"/>
+                </a:lnTo>
+                <a:lnTo>
+                  <a:pt x="0" y="120000"/>
+                </a:lnTo>
+                <a:close/>
+              </a:path>
+            </a:pathLst>
+          </a:custGeom>
+          <a:noFill/>
+          <a:ln cap="flat" cmpd="sng" w="9525">
+            <a:solidFill>
+              <a:srgbClr val="000000"/>
+            </a:solidFill>
+            <a:prstDash val="solid"/>
+            <a:round/>
+            <a:headEnd len="sm" w="sm" type="none"/>
+            <a:tailEnd len="sm" w="sm" type="none"/>
+          </a:ln>
+        </p:spPr>
+      </p:sp>
+      <p:sp>
+        <p:nvSpPr>
+          <p:cNvPr id="4" name="Google Shape;4;n"/>
+          <p:cNvSpPr txBox="1"/>
+          <p:nvPr>
+            <p:ph idx="1" type="body"/>
+          </p:nvPr>
+        </p:nvSpPr>
+        <p:spPr>
+          <a:xfrm>
+            <a:off x="685800" y="4343400"/>
+            <a:ext cx="5486400" cy="4114800"/>
+          </a:xfrm>
+          <a:prstGeom prst="rect">
+            <a:avLst/>
+          </a:prstGeom>
+          <a:noFill/>
+          <a:ln>
+            <a:noFill/>
+          </a:ln>
+        </p:spPr>
+        <p:txBody>
+          <a:bodyPr anchorCtr="0" anchor="t" bIns="91425" lIns="91425" spcFirstLastPara="1" rIns="91425" wrap="square" tIns="91425">
+            <a:noAutofit/>
+          </a:bodyPr>
+          <a:lstStyle>
+            <a:lvl1pPr indent="-298450" lvl="0" marL="457200">
+              <a:spcBef>
+                <a:spcPts val="0"/>
+              </a:spcBef>
+              <a:spcAft>
+                <a:spcPts val="0"/>
+              </a:spcAft>
+              <a:buSzPts val="1100"/>
+              <a:buChar char="●"/>
+              <a:defRPr sz="1100"/>
+            </a:lvl1pPr>
+            <a:lvl2pPr indent="-298450" lvl="1" marL="914400">
+              <a:spcBef>
+                <a:spcPts val="0"/>
+              </a:spcBef>
+              <a:spcAft>
+                <a:spcPts val="0"/>
+              </a:spcAft>
+              <a:buSzPts val="1100"/>
+              <a:buChar char="○"/>
+              <a:defRPr sz="1100"/>
+            </a:lvl2pPr>
+            <a:lvl3pPr indent="-298450" lvl="2" marL="1371600">
+              <a:spcBef>
+                <a:spcPts val="0"/>
+              </a:spcBef>
+              <a:spcAft>
+                <a:spcPts val="0"/>
+              </a:spcAft>
+              <a:buSzPts val="1100"/>
+              <a:buChar char="■"/>
+              <a:defRPr sz="1100"/>
+            </a:lvl3pPr>
+            <a:lvl4pPr indent="-298450" lvl="3" marL="1828800">
+              <a:spcBef>
+                <a:spcPts val="0"/>
+              </a:spcBef>
+              <a:spcAft>
+                <a:spcPts val="0"/>
+              </a:spcAft>
+              <a:buSzPts val="1100"/>
+              <a:buChar char="●"/>
+              <a:defRPr sz="1100"/>
+            </a:lvl4pPr>
+            <a:lvl5pPr indent="-298450" lvl="4" marL="2286000">
+              <a:spcBef>
+                <a:spcPts val="0"/>
+              </a:spcBef>
+              <a:spcAft>
+                <a:spcPts val="0"/>
+              </a:spcAft>
+              <a:buSzPts val="1100"/>
+              <a:buChar char="○"/>
+              <a:defRPr sz="1100"/>
+            </a:lvl5pPr>
+            <a:lvl6pPr indent="-298450" lvl="5" marL="2743200">
+              <a:spcBef>
+                <a:spcPts val="0"/>
+              </a:spcBef>
+              <a:spcAft>
+                <a:spcPts val="0"/>
+              </a:spcAft>
+              <a:buSzPts val="1100"/>
+              <a:buChar char="■"/>
+              <a:defRPr sz="1100"/>
+            </a:lvl6pPr>
+            <a:lvl7pPr indent="-298450" lvl="6" marL="3200400">
+              <a:spcBef>
+                <a:spcPts val="0"/>
+              </a:spcBef>
+              <a:spcAft>
+                <a:spcPts val="0"/>
+              </a:spcAft>
+              <a:buSzPts val="1100"/>
+              <a:buChar char="●"/>
+              <a:defRPr sz="1100"/>
+            </a:lvl7pPr>
+            <a:lvl8pPr indent="-298450" lvl="7" marL="3657600">
+              <a:spcBef>
+                <a:spcPts val="0"/>
+              </a:spcBef>
+              <a:spcAft>
+                <a:spcPts val="0"/>
+              </a:spcAft>
+              <a:buSzPts val="1100"/>
+              <a:buChar char="○"/>
+              <a:defRPr sz="1100"/>
+            </a:lvl8pPr>
+            <a:lvl9pPr indent="-298450" lvl="8" marL="4114800">
+              <a:spcBef>
+                <a:spcPts val="0"/>
+              </a:spcBef>
+              <a:spcAft>
+                <a:spcPts val="0"/>
+              </a:spcAft>
+              <a:buSzPts val="1100"/>
+              <a:buChar char="■"/>
+              <a:defRPr sz="1100"/>
+            </a:lvl9pPr>
+          </a:lstStyle>
+          <a:p/>
+        </p:txBody>
+      </p:sp>
+    </p:spTree>
+  </p:cSld>
+  <p:clrMap accent1="accent1" accent2="accent2" accent3="accent3" accent4="accent4" accent5="accent5" accent6="accent6" bg1="lt1" bg2="dk2" tx1="dk1" tx2="lt2" folHlink="folHlink" hlink="hlink"/>
+  <p:notesStyle>
+    <a:defPPr lvl="0" marR="0" rtl="0" algn="l">
+      <a:lnSpc>
+        <a:spcPct val="100000"/>
+      </a:lnSpc>
+      <a:spcBef>
+        <a:spcPts val="0"/>
+      </a:spcBef>
+      <a:spcAft>
+        <a:spcPts val="0"/>
+      </a:spcAft>
+    </a:defPPr>
+    <a:lvl1pPr lvl="0" marR="0" rtl="0" algn="l">
+      <a:lnSpc>
+        <a:spcPct val="100000"/>
+      </a:lnSpc>
+      <a:spcBef>
+        <a:spcPts val="0"/>
+      </a:spcBef>
+      <a:spcAft>
+        <a:spcPts val="0"/>
+      </a:spcAft>
+      <a:buClr>
+        <a:srgbClr val="000000"/>
+      </a:buClr>
+      <a:buFont typeface="Arial"/>
+      <a:defRPr b="0" i="0" sz="1400" u="none" cap="none" strike="noStrike">
+        <a:solidFill>
+          <a:srgbClr val="000000"/>
+        </a:solidFill>
+        <a:latin typeface="Arial"/>
+        <a:ea typeface="Arial"/>
+        <a:cs typeface="Arial"/>
+        <a:sym typeface="Arial"/>
+      </a:defRPr>
+    </a:lvl1pPr>
+    <a:lvl2pPr lvl="1" marR="0" rtl="0" algn="l">
+      <a:lnSpc>
+        <a:spcPct val="100000"/>
+      </a:lnSpc>
+      <a:spcBef>
+        <a:spcPts val="0"/>
+      </a:spcBef>
+      <a:spcAft>
+        <a:spcPts val="0"/>
+      </a:spcAft>
+      <a:buClr>
+        <a:srgbClr val="000000"/>
+      </a:buClr>
+      <a:buFont typeface="Arial"/>
+      <a:defRPr b="0" i="0" sz="1400" u="none" cap="none" strike="noStrike">
+        <a:solidFill>
+          <a:srgbClr val="000000"/>
+        </a:solidFill>
+        <a:latin typeface="Arial"/>
+        <a:ea typeface="Arial"/>
+        <a:cs typeface="Arial"/>
+        <a:sym typeface="Arial"/>
+      </a:defRPr>
+    </a:lvl2pPr>
+    <a:lvl3pPr lvl="2" marR="0" rtl="0" algn="l">
+      <a:lnSpc>
+        <a:spcPct val="100000"/>
+      </a:lnSpc>
+      <a:spcBef>
+        <a:spcPts val="0"/>
+      </a:spcBef>
+      <a:spcAft>
+        <a:spcPts val="0"/>
+      </a:spcAft>
+      <a:buClr>
+        <a:srgbClr val="000000"/>
+      </a:buClr>
+      <a:buFont typeface="Arial"/>
+      <a:defRPr b="0" i="0" sz="1400" u="none" cap="none" strike="noStrike">
+        <a:solidFill>
+          <a:srgbClr val="000000"/>
+        </a:solidFill>
+        <a:latin typeface="Arial"/>
+        <a:ea typeface="Arial"/>
+        <a:cs typeface="Arial"/>
+        <a:sym typeface="Arial"/>
+      </a:defRPr>
+    </a:lvl3pPr>
+    <a:lvl4pPr lvl="3" marR="0" rtl="0" algn="l">
+      <a:lnSpc>
+        <a:spcPct val="100000"/>
+      </a:lnSpc>
+      <a:spcBef>
+        <a:spcPts val="0"/>
+      </a:spcBef>
+      <a:spcAft>
+        <a:spcPts val="0"/>
+      </a:spcAft>
+      <a:buClr>
+        <a:srgbClr val="000000"/>
+      </a:buClr>
+      <a:buFont typeface="Arial"/>
+      <a:defRPr b="0" i="0" sz="1400" u="none" cap="none" strike="noStrike">
+        <a:solidFill>
+          <a:srgbClr val="000000"/>
+        </a:solidFill>
+        <a:latin typeface="Arial"/>
+        <a:ea typeface="Arial"/>
+        <a:cs typeface="Arial"/>
+        <a:sym typeface="Arial"/>
+      </a:defRPr>
+    </a:lvl4pPr>
+    <a:lvl5pPr lvl="4" marR="0" rtl="0" algn="l">
+      <a:lnSpc>
+        <a:spcPct val="100000"/>
+      </a:lnSpc>
+      <a:spcBef>
+        <a:spcPts val="0"/>
+      </a:spcBef>
+      <a:spcAft>
+        <a:spcPts val="0"/>
+      </a:spcAft>
+      <a:buClr>
+        <a:srgbClr val="000000"/>
+      </a:buClr>
+      <a:buFont typeface="Arial"/>
+      <a:defRPr b="0" i="0" sz="1400" u="none" cap="none" strike="noStrike">
+        <a:solidFill>
+          <a:srgbClr val="000000"/>
+        </a:solidFill>
+        <a:latin typeface="Arial"/>
+        <a:ea typeface="Arial"/>
+        <a:cs typeface="Arial"/>
+        <a:sym typeface="Arial"/>
+      </a:defRPr>
+    </a:lvl5pPr>
+    <a:lvl6pPr lvl="5" marR="0" rtl="0" algn="l">
+      <a:lnSpc>
+        <a:spcPct val="100000"/>
+      </a:lnSpc>
+      <a:spcBef>
+        <a:spcPts val="0"/>
+      </a:spcBef>
+      <a:spcAft>
+        <a:spcPts val="0"/>
+      </a:spcAft>
+      <a:buClr>
+        <a:srgbClr val="000000"/>
+      </a:buClr>
+      <a:buFont typeface="Arial"/>
+      <a:defRPr b="0" i="0" sz="1400" u="none" cap="none" strike="noStrike">
+        <a:solidFill>
+          <a:srgbClr val="000000"/>
+        </a:solidFill>
+        <a:latin typeface="Arial"/>
+        <a:ea typeface="Arial"/>
+        <a:cs typeface="Arial"/>
+        <a:sym typeface="Arial"/>
+      </a:defRPr>
+    </a:lvl6pPr>
+    <a:lvl7pPr lvl="6" marR="0" rtl="0" algn="l">
+      <a:lnSpc>
+        <a:spcPct val="100000"/>
+      </a:lnSpc>
+      <a:spcBef>
+        <a:spcPts val="0"/>
+      </a:spcBef>
+      <a:spcAft>
+        <a:spcPts val="0"/>
+      </a:spcAft>
+      <a:buClr>
+        <a:srgbClr val="000000"/>
+      </a:buClr>
+      <a:buFont typeface="Arial"/>
+      <a:defRPr b="0" i="0" sz="1400" u="none" cap="none" strike="noStrike">
+        <a:solidFill>
+          <a:srgbClr val="000000"/>
+        </a:solidFill>
+        <a:latin typeface="Arial"/>
+        <a:ea typeface="Arial"/>
+        <a:cs typeface="Arial"/>
+        <a:sym typeface="Arial"/>
+      </a:defRPr>
+    </a:lvl7pPr>
+    <a:lvl8pPr lvl="7" marR="0" rtl="0" algn="l">
+      <a:lnSpc>
+        <a:spcPct val="100000"/>
+      </a:lnSpc>
+      <a:spcBef>
+        <a:spcPts val="0"/>
+      </a:spcBef>
+      <a:spcAft>
+        <a:spcPts val="0"/>
+      </a:spcAft>
+      <a:buClr>
+        <a:srgbClr val="000000"/>
+      </a:buClr>
+      <a:buFont typeface="Arial"/>
+      <a:defRPr b="0" i="0" sz="1400" u="none" cap="none" strike="noStrike">
+        <a:solidFill>
+          <a:srgbClr val="000000"/>
+        </a:solidFill>
+        <a:latin typeface="Arial"/>
+        <a:ea typeface="Arial"/>
+        <a:cs typeface="Arial"/>
+        <a:sym typeface="Arial"/>
+      </a:defRPr>
+    </a:lvl8pPr>
+    <a:lvl9pPr lvl="8" marR="0" rtl="0" algn="l">
+      <a:lnSpc>
+        <a:spcPct val="100000"/>
+      </a:lnSpc>
+      <a:spcBef>
+        <a:spcPts val="0"/>
+      </a:spcBef>
+      <a:spcAft>
+        <a:spcPts val="0"/>
+      </a:spcAft>
+      <a:buClr>
+        <a:srgbClr val="000000"/>
+      </a:buClr>
+      <a:buFont typeface="Arial"/>
+      <a:defRPr b="0" i="0" sz="1400" u="none" cap="none" strike="noStrike">
+        <a:solidFill>
+          <a:srgbClr val="000000"/>
+        </a:solidFill>
+        <a:latin typeface="Arial"/>
+        <a:ea typeface="Arial"/>
+        <a:cs typeface="Arial"/>
+        <a:sym typeface="Arial"/>
+      </a:defRPr>
+    </a:lvl9pPr>
+  </p:notesStyle>
+</p:notesMaster>
+</file>
+
+<file path=ppt\notesSlides\notesSlide1.xml><?xml version="1.0" encoding="utf-8"?>
+<p:notes xmlns:a="http://schemas.openxmlformats.org/drawingml/2006/main" xmlns:r="http://schemas.openxmlformats.org/officeDocument/2006/relationships" xmlns:mc="http://schemas.openxmlformats.org/markup-compatibility/2006" xmlns:mv="urn:schemas-microsoft-com:mac:vml" xmlns:p="http://schemas.openxmlformats.org/presentationml/2006/main" xmlns:c="http://schemas.openxmlformats.org/drawingml/2006/chart" xmlns:dgm="http://schemas.openxmlformats.org/drawingml/2006/diagram" xmlns:o="urn:schemas-microsoft-com:office:office" xmlns:v="urn:schemas-microsoft-com:vml" xmlns:pvml="urn:schemas-microsoft-com:office:powerpoint" xmlns:com="http://schemas.openxmlformats.org/drawingml/2006/compatibility" xmlns:p14="http://schemas.microsoft.com/office/powerpoint/2010/main" xmlns:p15="http://schemas.microsoft.com/office/powerpoint/2012/main" xmlns:ahyp="http://schemas.microsoft.com/office/drawing/2018/hyperlinkcolor" showMasterPhAnim="0" showMasterSp="0">
+  <p:cSld>
+    <p:spTree>
+      <p:nvGrpSpPr>
+        <p:cNvPr id="50" name="Shape 50"/>
+        <p:cNvGrpSpPr/>
+        <p:nvPr/>
+      </p:nvGrpSpPr>
+      <p:grpSpPr>
+        <a:xfrm>
+          <a:off x="0" y="0"/>
+          <a:ext cx="0" cy="0"/>
+          <a:chOff x="0" y="0"/>
+          <a:chExt cx="0" cy="0"/>
+        </a:xfrm>
+      </p:grpSpPr>
+      <p:sp>
+        <p:nvSpPr>
+          <p:cNvPr id="51" name="Google Shape;51;p:notes"/>
+          <p:cNvSpPr/>
+          <p:nvPr>
+            <p:ph idx="2" type="sldImg"/>
+          </p:nvPr>
+        </p:nvSpPr>
+        <p:spPr>
+          <a:xfrm>
+            <a:off x="381300" y="685800"/>
+            <a:ext cx="6096075" cy="3429000"/>
+          </a:xfrm>
+          <a:custGeom>
+            <a:rect b="b" l="l" r="r" t="t"/>
+            <a:pathLst>
+              <a:path extrusionOk="0" h="120000" w="120000">
+                <a:moveTo>
+                  <a:pt x="0" y="0"/>
+                </a:moveTo>
+                <a:lnTo>
+                  <a:pt x="120000" y="0"/>
+                </a:lnTo>
+                <a:lnTo>
+                  <a:pt x="120000" y="120000"/>
+                </a:lnTo>
+                <a:lnTo>
+                  <a:pt x="0" y="120000"/>
+                </a:lnTo>
+                <a:close/>
+              </a:path>
+            </a:pathLst>
+          </a:custGeom>
+        </p:spPr>
+      </p:sp>
+      <p:sp>
+        <p:nvSpPr>
+          <p:cNvPr id="52" name="Google Shape;52;p:notes"/>
+          <p:cNvSpPr txBox="1"/>
+          <p:nvPr>
+            <p:ph idx="1" type="body"/>
+          </p:nvPr>
+        </p:nvSpPr>
+        <p:spPr>
+          <a:xfrm>
+            <a:off x="685800" y="4343400"/>
+            <a:ext cx="5486400" cy="4114800"/>
+          </a:xfrm>
+          <a:prstGeom prst="rect">
+            <a:avLst/>
+          </a:prstGeom>
+        </p:spPr>
+        <p:txBody>
+          <a:bodyPr anchorCtr="0" anchor="t" bIns="91425" lIns="91425" spcFirstLastPara="1" rIns="91425" wrap="square" tIns="91425">
+            <a:noAutofit/>
+          </a:bodyPr>
+          <a:lstStyle/>
+          <a:p>
+            <a:pPr indent="0" lvl="0" marL="0" rtl="0" algn="l">
+              <a:spcBef>
+                <a:spcPts val="0"/>
+              </a:spcBef>
+              <a:spcAft>
+                <a:spcPts val="0"/>
+              </a:spcAft>
+              <a:buNone/>
+            </a:pPr>
+            <a:r>
+              <a:t/>
+            </a:r>
+            <a:endParaRPr/>
+          </a:p>
+        </p:txBody>
+      </p:sp>
+    </p:spTree>
+  </p:cSld>
+  <p:clrMapOvr>
+    <a:masterClrMapping/>
+  </p:clrMapOvr>
+</p:notes>
+</file>
+
+<file path=ppt\notesSlides\notesSlide10.xml><?xml version="1.0" encoding="utf-8"?>
+<p:notes xmlns:a="http://schemas.openxmlformats.org/drawingml/2006/main" xmlns:r="http://schemas.openxmlformats.org/officeDocument/2006/relationships" xmlns:mc="http://schemas.openxmlformats.org/markup-compatibility/2006" xmlns:mv="urn:schemas-microsoft-com:mac:vml" xmlns:p="http://schemas.openxmlformats.org/presentationml/2006/main" xmlns:c="http://schemas.openxmlformats.org/drawingml/2006/chart" xmlns:dgm="http://schemas.openxmlformats.org/drawingml/2006/diagram" xmlns:o="urn:schemas-microsoft-com:office:office" xmlns:v="urn:schemas-microsoft-com:vml" xmlns:pvml="urn:schemas-microsoft-com:office:powerpoint" xmlns:com="http://schemas.openxmlformats.org/drawingml/2006/compatibility" xmlns:p14="http://schemas.microsoft.com/office/powerpoint/2010/main" xmlns:p15="http://schemas.microsoft.com/office/powerpoint/2012/main" xmlns:ahyp="http://schemas.microsoft.com/office/drawing/2018/hyperlinkcolor" showMasterPhAnim="0" showMasterSp="0">
+  <p:cSld>
+    <p:spTree>
+      <p:nvGrpSpPr>
+        <p:cNvPr id="108" name="Shape 108"/>
+        <p:cNvGrpSpPr/>
+        <p:nvPr/>
+      </p:nvGrpSpPr>
+      <p:grpSpPr>
+        <a:xfrm>
+          <a:off x="0" y="0"/>
+          <a:ext cx="0" cy="0"/>
+          <a:chOff x="0" y="0"/>
+          <a:chExt cx="0" cy="0"/>
+        </a:xfrm>
+      </p:grpSpPr>
+      <p:sp>
+        <p:nvSpPr>
+          <p:cNvPr id="109" name="Google Shape;109;gb0586cafee_0_49:notes"/>
+          <p:cNvSpPr/>
+          <p:nvPr>
+            <p:ph idx="2" type="sldImg"/>
+          </p:nvPr>
+        </p:nvSpPr>
+        <p:spPr>
+          <a:xfrm>
+            <a:off x="381300" y="685800"/>
+            <a:ext cx="6096000" cy="3429000"/>
+          </a:xfrm>
+          <a:custGeom>
+            <a:rect b="b" l="l" r="r" t="t"/>
+            <a:pathLst>
+              <a:path extrusionOk="0" h="120000" w="120000">
+                <a:moveTo>
+                  <a:pt x="0" y="0"/>
+                </a:moveTo>
+                <a:lnTo>
+                  <a:pt x="120000" y="0"/>
+                </a:lnTo>
+                <a:lnTo>
+                  <a:pt x="120000" y="120000"/>
+                </a:lnTo>
+                <a:lnTo>
+                  <a:pt x="0" y="120000"/>
+                </a:lnTo>
+                <a:close/>
+              </a:path>
+            </a:pathLst>
+          </a:custGeom>
+        </p:spPr>
+      </p:sp>
+      <p:sp>
+        <p:nvSpPr>
+          <p:cNvPr id="110" name="Google Shape;110;gb0586cafee_0_49:notes"/>
+          <p:cNvSpPr txBox="1"/>
+          <p:nvPr>
+            <p:ph idx="1" type="body"/>
+          </p:nvPr>
+        </p:nvSpPr>
+        <p:spPr>
+          <a:xfrm>
+            <a:off x="685800" y="4343400"/>
+            <a:ext cx="5486400" cy="4114800"/>
+          </a:xfrm>
+          <a:prstGeom prst="rect">
+            <a:avLst/>
+          </a:prstGeom>
+        </p:spPr>
+        <p:txBody>
+          <a:bodyPr anchorCtr="0" anchor="t" bIns="91425" lIns="91425" spcFirstLastPara="1" rIns="91425" wrap="square" tIns="91425">
+            <a:noAutofit/>
+          </a:bodyPr>
+          <a:lstStyle/>
+          <a:p>
+            <a:pPr indent="0" lvl="0" marL="0" rtl="0" algn="l">
+              <a:spcBef>
+                <a:spcPts val="0"/>
+              </a:spcBef>
+              <a:spcAft>
+                <a:spcPts val="0"/>
+              </a:spcAft>
+              <a:buNone/>
+            </a:pPr>
+            <a:r>
+              <a:t/>
+            </a:r>
+            <a:endParaRPr/>
+          </a:p>
+        </p:txBody>
+      </p:sp>
+    </p:spTree>
+  </p:cSld>
+  <p:clrMapOvr>
+    <a:masterClrMapping/>
+  </p:clrMapOvr>
+</p:notes>
+</file>
+
+<file path=ppt\notesSlides\notesSlide11.xml><?xml version="1.0" encoding="utf-8"?>
+<p:notes xmlns:a="http://schemas.openxmlformats.org/drawingml/2006/main" xmlns:r="http://schemas.openxmlformats.org/officeDocument/2006/relationships" xmlns:mc="http://schemas.openxmlformats.org/markup-compatibility/2006" xmlns:mv="urn:schemas-microsoft-com:mac:vml" xmlns:p="http://schemas.openxmlformats.org/presentationml/2006/main" xmlns:c="http://schemas.openxmlformats.org/drawingml/2006/chart" xmlns:dgm="http://schemas.openxmlformats.org/drawingml/2006/diagram" xmlns:o="urn:schemas-microsoft-com:office:office" xmlns:v="urn:schemas-microsoft-com:vml" xmlns:pvml="urn:schemas-microsoft-com:office:powerpoint" xmlns:com="http://schemas.openxmlformats.org/drawingml/2006/compatibility" xmlns:p14="http://schemas.microsoft.com/office/powerpoint/2010/main" xmlns:p15="http://schemas.microsoft.com/office/powerpoint/2012/main" xmlns:ahyp="http://schemas.microsoft.com/office/drawing/2018/hyperlinkcolor" showMasterPhAnim="0" showMasterSp="0">
+  <p:cSld>
+    <p:spTree>
+      <p:nvGrpSpPr>
+        <p:cNvPr id="115" name="Shape 115"/>
+        <p:cNvGrpSpPr/>
+        <p:nvPr/>
+      </p:nvGrpSpPr>
+      <p:grpSpPr>
+        <a:xfrm>
+          <a:off x="0" y="0"/>
+          <a:ext cx="0" cy="0"/>
+          <a:chOff x="0" y="0"/>
+          <a:chExt cx="0" cy="0"/>
+        </a:xfrm>
+      </p:grpSpPr>
+      <p:sp>
+        <p:nvSpPr>
+          <p:cNvPr id="116" name="Google Shape;116;gb0586cafee_0_55:notes"/>
+          <p:cNvSpPr/>
+          <p:nvPr>
+            <p:ph idx="2" type="sldImg"/>
+          </p:nvPr>
+        </p:nvSpPr>
+        <p:spPr>
+          <a:xfrm>
+            <a:off x="381300" y="685800"/>
+            <a:ext cx="6096000" cy="3429000"/>
+          </a:xfrm>
+          <a:custGeom>
+            <a:rect b="b" l="l" r="r" t="t"/>
+            <a:pathLst>
+              <a:path extrusionOk="0" h="120000" w="120000">
+                <a:moveTo>
+                  <a:pt x="0" y="0"/>
+                </a:moveTo>
+                <a:lnTo>
+                  <a:pt x="120000" y="0"/>
+                </a:lnTo>
+                <a:lnTo>
+                  <a:pt x="120000" y="120000"/>
+                </a:lnTo>
+                <a:lnTo>
+                  <a:pt x="0" y="120000"/>
+                </a:lnTo>
+                <a:close/>
+              </a:path>
+            </a:pathLst>
+          </a:custGeom>
+        </p:spPr>
+      </p:sp>
+      <p:sp>
+        <p:nvSpPr>
+          <p:cNvPr id="117" name="Google Shape;117;gb0586cafee_0_55:notes"/>
+          <p:cNvSpPr txBox="1"/>
+          <p:nvPr>
+            <p:ph idx="1" type="body"/>
+          </p:nvPr>
+        </p:nvSpPr>
+        <p:spPr>
+          <a:xfrm>
+            <a:off x="685800" y="4343400"/>
+            <a:ext cx="5486400" cy="4114800"/>
+          </a:xfrm>
+          <a:prstGeom prst="rect">
+            <a:avLst/>
+          </a:prstGeom>
+        </p:spPr>
+        <p:txBody>
+          <a:bodyPr anchorCtr="0" anchor="t" bIns="91425" lIns="91425" spcFirstLastPara="1" rIns="91425" wrap="square" tIns="91425">
+            <a:noAutofit/>
+          </a:bodyPr>
+          <a:lstStyle/>
+          <a:p>
+            <a:pPr indent="0" lvl="0" marL="0" rtl="0" algn="l">
+              <a:spcBef>
+                <a:spcPts val="0"/>
+              </a:spcBef>
+              <a:spcAft>
+                <a:spcPts val="0"/>
+              </a:spcAft>
+              <a:buNone/>
+            </a:pPr>
+            <a:r>
+              <a:t/>
+            </a:r>
+            <a:endParaRPr/>
+          </a:p>
+        </p:txBody>
+      </p:sp>
+    </p:spTree>
+  </p:cSld>
+  <p:clrMapOvr>
+    <a:masterClrMapping/>
+  </p:clrMapOvr>
+</p:notes>
+</file>
+
+<file path=ppt\notesSlides\notesSlide12.xml><?xml version="1.0" encoding="utf-8"?>
+<p:notes xmlns:a="http://schemas.openxmlformats.org/drawingml/2006/main" xmlns:r="http://schemas.openxmlformats.org/officeDocument/2006/relationships" xmlns:mc="http://schemas.openxmlformats.org/markup-compatibility/2006" xmlns:mv="urn:schemas-microsoft-com:mac:vml" xmlns:p="http://schemas.openxmlformats.org/presentationml/2006/main" xmlns:c="http://schemas.openxmlformats.org/drawingml/2006/chart" xmlns:dgm="http://schemas.openxmlformats.org/drawingml/2006/diagram" xmlns:o="urn:schemas-microsoft-com:office:office" xmlns:v="urn:schemas-microsoft-com:vml" xmlns:pvml="urn:schemas-microsoft-com:office:powerpoint" xmlns:com="http://schemas.openxmlformats.org/drawingml/2006/compatibility" xmlns:p14="http://schemas.microsoft.com/office/powerpoint/2010/main" xmlns:p15="http://schemas.microsoft.com/office/powerpoint/2012/main" xmlns:ahyp="http://schemas.microsoft.com/office/drawing/2018/hyperlinkcolor" showMasterPhAnim="0" showMasterSp="0">
+  <p:cSld>
+    <p:spTree>
+      <p:nvGrpSpPr>
+        <p:cNvPr id="121" name="Shape 121"/>
+        <p:cNvGrpSpPr/>
+        <p:nvPr/>
+      </p:nvGrpSpPr>
+      <p:grpSpPr>
+        <a:xfrm>
+          <a:off x="0" y="0"/>
+          <a:ext cx="0" cy="0"/>
+          <a:chOff x="0" y="0"/>
+          <a:chExt cx="0" cy="0"/>
+        </a:xfrm>
+      </p:grpSpPr>
+      <p:sp>
+        <p:nvSpPr>
+          <p:cNvPr id="122" name="Google Shape;122;gb0586cafee_0_60:notes"/>
+          <p:cNvSpPr/>
+          <p:nvPr>
+            <p:ph idx="2" type="sldImg"/>
+          </p:nvPr>
+        </p:nvSpPr>
+        <p:spPr>
+          <a:xfrm>
+            <a:off x="381300" y="685800"/>
+            <a:ext cx="6096000" cy="3429000"/>
+          </a:xfrm>
+          <a:custGeom>
+            <a:rect b="b" l="l" r="r" t="t"/>
+            <a:pathLst>
+              <a:path extrusionOk="0" h="120000" w="120000">
+                <a:moveTo>
+                  <a:pt x="0" y="0"/>
+                </a:moveTo>
+                <a:lnTo>
+                  <a:pt x="120000" y="0"/>
+                </a:lnTo>
+                <a:lnTo>
+                  <a:pt x="120000" y="120000"/>
+                </a:lnTo>
+                <a:lnTo>
+                  <a:pt x="0" y="120000"/>
+                </a:lnTo>
+                <a:close/>
+              </a:path>
+            </a:pathLst>
+          </a:custGeom>
+        </p:spPr>
+      </p:sp>
+      <p:sp>
+        <p:nvSpPr>
+          <p:cNvPr id="123" name="Google Shape;123;gb0586cafee_0_60:notes"/>
+          <p:cNvSpPr txBox="1"/>
+          <p:nvPr>
+            <p:ph idx="1" type="body"/>
+          </p:nvPr>
+        </p:nvSpPr>
+        <p:spPr>
+          <a:xfrm>
+            <a:off x="685800" y="4343400"/>
+            <a:ext cx="5486400" cy="4114800"/>
+          </a:xfrm>
+          <a:prstGeom prst="rect">
+            <a:avLst/>
+          </a:prstGeom>
+        </p:spPr>
+        <p:txBody>
+          <a:bodyPr anchorCtr="0" anchor="t" bIns="91425" lIns="91425" spcFirstLastPara="1" rIns="91425" wrap="square" tIns="91425">
+            <a:noAutofit/>
+          </a:bodyPr>
+          <a:lstStyle/>
+          <a:p>
+            <a:pPr indent="0" lvl="0" marL="0" rtl="0" algn="l">
+              <a:spcBef>
+                <a:spcPts val="0"/>
+              </a:spcBef>
+              <a:spcAft>
+                <a:spcPts val="0"/>
+              </a:spcAft>
+              <a:buNone/>
+            </a:pPr>
+            <a:r>
+              <a:t/>
+            </a:r>
+            <a:endParaRPr/>
+          </a:p>
+        </p:txBody>
+      </p:sp>
+    </p:spTree>
+  </p:cSld>
+  <p:clrMapOvr>
+    <a:masterClrMapping/>
+  </p:clrMapOvr>
+</p:notes>
+</file>
+
+<file path=ppt\notesSlides\notesSlide13.xml><?xml version="1.0" encoding="utf-8"?>
+<p:notes xmlns:a="http://schemas.openxmlformats.org/drawingml/2006/main" xmlns:r="http://schemas.openxmlformats.org/officeDocument/2006/relationships" xmlns:mc="http://schemas.openxmlformats.org/markup-compatibility/2006" xmlns:mv="urn:schemas-microsoft-com:mac:vml" xmlns:p="http://schemas.openxmlformats.org/presentationml/2006/main" xmlns:c="http://schemas.openxmlformats.org/drawingml/2006/chart" xmlns:dgm="http://schemas.openxmlformats.org/drawingml/2006/diagram" xmlns:o="urn:schemas-microsoft-com:office:office" xmlns:v="urn:schemas-microsoft-com:vml" xmlns:pvml="urn:schemas-microsoft-com:office:powerpoint" xmlns:com="http://schemas.openxmlformats.org/drawingml/2006/compatibility" xmlns:p14="http://schemas.microsoft.com/office/powerpoint/2010/main" xmlns:p15="http://schemas.microsoft.com/office/powerpoint/2012/main" xmlns:ahyp="http://schemas.microsoft.com/office/drawing/2018/hyperlinkcolor" showMasterPhAnim="0" showMasterSp="0">
+  <p:cSld>
+    <p:spTree>
+      <p:nvGrpSpPr>
+        <p:cNvPr id="127" name="Shape 127"/>
+        <p:cNvGrpSpPr/>
+        <p:nvPr/>
+      </p:nvGrpSpPr>
+      <p:grpSpPr>
+        <a:xfrm>
+          <a:off x="0" y="0"/>
+          <a:ext cx="0" cy="0"/>
+          <a:chOff x="0" y="0"/>
+          <a:chExt cx="0" cy="0"/>
+        </a:xfrm>
+      </p:grpSpPr>
+      <p:sp>
+        <p:nvSpPr>
+          <p:cNvPr id="128" name="Google Shape;128;gb06be9f2b7_0_0:notes"/>
+          <p:cNvSpPr/>
+          <p:nvPr>
+            <p:ph idx="2" type="sldImg"/>
+          </p:nvPr>
+        </p:nvSpPr>
+        <p:spPr>
+          <a:xfrm>
+            <a:off x="381300" y="685800"/>
+            <a:ext cx="6096000" cy="3429000"/>
+          </a:xfrm>
+          <a:custGeom>
+            <a:rect b="b" l="l" r="r" t="t"/>
+            <a:pathLst>
+              <a:path extrusionOk="0" h="120000" w="120000">
+                <a:moveTo>
+                  <a:pt x="0" y="0"/>
+                </a:moveTo>
+                <a:lnTo>
+                  <a:pt x="120000" y="0"/>
+                </a:lnTo>
+                <a:lnTo>
+                  <a:pt x="120000" y="120000"/>
+                </a:lnTo>
+                <a:lnTo>
+                  <a:pt x="0" y="120000"/>
+                </a:lnTo>
+                <a:close/>
+              </a:path>
+            </a:pathLst>
+          </a:custGeom>
+        </p:spPr>
+      </p:sp>
+      <p:sp>
+        <p:nvSpPr>
+          <p:cNvPr id="129" name="Google Shape;129;gb06be9f2b7_0_0:notes"/>
+          <p:cNvSpPr txBox="1"/>
+          <p:nvPr>
+            <p:ph idx="1" type="body"/>
+          </p:nvPr>
+        </p:nvSpPr>
+        <p:spPr>
+          <a:xfrm>
+            <a:off x="685800" y="4343400"/>
+            <a:ext cx="5486400" cy="4114800"/>
+          </a:xfrm>
+          <a:prstGeom prst="rect">
+            <a:avLst/>
+          </a:prstGeom>
+        </p:spPr>
+        <p:txBody>
+          <a:bodyPr anchorCtr="0" anchor="t" bIns="91425" lIns="91425" spcFirstLastPara="1" rIns="91425" wrap="square" tIns="91425">
+            <a:noAutofit/>
+          </a:bodyPr>
+          <a:lstStyle/>
+          <a:p>
+            <a:pPr indent="0" lvl="0" marL="0" rtl="0" algn="l">
+              <a:spcBef>
+                <a:spcPts val="0"/>
+              </a:spcBef>
+              <a:spcAft>
+                <a:spcPts val="0"/>
+              </a:spcAft>
+              <a:buNone/>
+            </a:pPr>
+            <a:r>
+              <a:t/>
+            </a:r>
+            <a:endParaRPr/>
+          </a:p>
+        </p:txBody>
+      </p:sp>
+    </p:spTree>
+  </p:cSld>
+  <p:clrMapOvr>
+    <a:masterClrMapping/>
+  </p:clrMapOvr>
+</p:notes>
+</file>
+
+<file path=ppt\notesSlides\notesSlide2.xml><?xml version="1.0" encoding="utf-8"?>
+<p:notes xmlns:a="http://schemas.openxmlformats.org/drawingml/2006/main" xmlns:r="http://schemas.openxmlformats.org/officeDocument/2006/relationships" xmlns:mc="http://schemas.openxmlformats.org/markup-compatibility/2006" xmlns:mv="urn:schemas-microsoft-com:mac:vml" xmlns:p="http://schemas.openxmlformats.org/presentationml/2006/main" xmlns:c="http://schemas.openxmlformats.org/drawingml/2006/chart" xmlns:dgm="http://schemas.openxmlformats.org/drawingml/2006/diagram" xmlns:o="urn:schemas-microsoft-com:office:office" xmlns:v="urn:schemas-microsoft-com:vml" xmlns:pvml="urn:schemas-microsoft-com:office:powerpoint" xmlns:com="http://schemas.openxmlformats.org/drawingml/2006/compatibility" xmlns:p14="http://schemas.microsoft.com/office/powerpoint/2010/main" xmlns:p15="http://schemas.microsoft.com/office/powerpoint/2012/main" xmlns:ahyp="http://schemas.microsoft.com/office/drawing/2018/hyperlinkcolor" showMasterPhAnim="0" showMasterSp="0">
+  <p:cSld>
+    <p:spTree>
+      <p:nvGrpSpPr>
+        <p:cNvPr id="57" name="Shape 57"/>
+        <p:cNvGrpSpPr/>
+        <p:nvPr/>
+      </p:nvGrpSpPr>
+      <p:grpSpPr>
+        <a:xfrm>
+          <a:off x="0" y="0"/>
+          <a:ext cx="0" cy="0"/>
+          <a:chOff x="0" y="0"/>
+          <a:chExt cx="0" cy="0"/>
+        </a:xfrm>
+      </p:grpSpPr>
+      <p:sp>
+        <p:nvSpPr>
+          <p:cNvPr id="58" name="Google Shape;58;gb0586cafee_0_71:notes"/>
+          <p:cNvSpPr/>
+          <p:nvPr>
+            <p:ph idx="2" type="sldImg"/>
+          </p:nvPr>
+        </p:nvSpPr>
+        <p:spPr>
+          <a:xfrm>
+            <a:off x="381300" y="685800"/>
+            <a:ext cx="6096000" cy="3429000"/>
+          </a:xfrm>
+          <a:custGeom>
+            <a:rect b="b" l="l" r="r" t="t"/>
+            <a:pathLst>
+              <a:path extrusionOk="0" h="120000" w="120000">
+                <a:moveTo>
+                  <a:pt x="0" y="0"/>
+                </a:moveTo>
+                <a:lnTo>
+                  <a:pt x="120000" y="0"/>
+                </a:lnTo>
+                <a:lnTo>
+                  <a:pt x="120000" y="120000"/>
+                </a:lnTo>
+                <a:lnTo>
+                  <a:pt x="0" y="120000"/>
+                </a:lnTo>
+                <a:close/>
+              </a:path>
+            </a:pathLst>
+          </a:custGeom>
+        </p:spPr>
+      </p:sp>
+      <p:sp>
+        <p:nvSpPr>
+          <p:cNvPr id="59" name="Google Shape;59;gb0586cafee_0_71:notes"/>
+          <p:cNvSpPr txBox="1"/>
+          <p:nvPr>
+            <p:ph idx="1" type="body"/>
+          </p:nvPr>
+        </p:nvSpPr>
+        <p:spPr>
+          <a:xfrm>
+            <a:off x="685800" y="4343400"/>
+            <a:ext cx="5486400" cy="4114800"/>
+          </a:xfrm>
+          <a:prstGeom prst="rect">
+            <a:avLst/>
+          </a:prstGeom>
+        </p:spPr>
+        <p:txBody>
+          <a:bodyPr anchorCtr="0" anchor="t" bIns="91425" lIns="91425" spcFirstLastPara="1" rIns="91425" wrap="square" tIns="91425">
+            <a:noAutofit/>
+          </a:bodyPr>
+          <a:lstStyle/>
+          <a:p>
+            <a:pPr indent="0" lvl="0" marL="0" rtl="0" algn="l">
+              <a:spcBef>
+                <a:spcPts val="0"/>
+              </a:spcBef>
+              <a:spcAft>
+                <a:spcPts val="0"/>
+              </a:spcAft>
+              <a:buNone/>
+            </a:pPr>
+            <a:r>
+              <a:t/>
+            </a:r>
+            <a:endParaRPr/>
+          </a:p>
+        </p:txBody>
+      </p:sp>
+    </p:spTree>
+  </p:cSld>
+  <p:clrMapOvr>
+    <a:masterClrMapping/>
+  </p:clrMapOvr>
+</p:notes>
+</file>
+
+<file path=ppt\notesSlides\notesSlide3.xml><?xml version="1.0" encoding="utf-8"?>
+<p:notes xmlns:a="http://schemas.openxmlformats.org/drawingml/2006/main" xmlns:r="http://schemas.openxmlformats.org/officeDocument/2006/relationships" xmlns:mc="http://schemas.openxmlformats.org/markup-compatibility/2006" xmlns:mv="urn:schemas-microsoft-com:mac:vml" xmlns:p="http://schemas.openxmlformats.org/presentationml/2006/main" xmlns:c="http://schemas.openxmlformats.org/drawingml/2006/chart" xmlns:dgm="http://schemas.openxmlformats.org/drawingml/2006/diagram" xmlns:o="urn:schemas-microsoft-com:office:office" xmlns:v="urn:schemas-microsoft-com:vml" xmlns:pvml="urn:schemas-microsoft-com:office:powerpoint" xmlns:com="http://schemas.openxmlformats.org/drawingml/2006/compatibility" xmlns:p14="http://schemas.microsoft.com/office/powerpoint/2010/main" xmlns:p15="http://schemas.microsoft.com/office/powerpoint/2012/main" xmlns:ahyp="http://schemas.microsoft.com/office/drawing/2018/hyperlinkcolor" showMasterPhAnim="0" showMasterSp="0">
+  <p:cSld>
+    <p:spTree>
+      <p:nvGrpSpPr>
+        <p:cNvPr id="63" name="Shape 63"/>
+        <p:cNvGrpSpPr/>
+        <p:nvPr/>
+      </p:nvGrpSpPr>
+      <p:grpSpPr>
+        <a:xfrm>
+          <a:off x="0" y="0"/>
+          <a:ext cx="0" cy="0"/>
+          <a:chOff x="0" y="0"/>
+          <a:chExt cx="0" cy="0"/>
+        </a:xfrm>
+      </p:grpSpPr>
+      <p:sp>
+        <p:nvSpPr>
+          <p:cNvPr id="64" name="Google Shape;64;gb0586cafee_0_0:notes"/>
+          <p:cNvSpPr/>
+          <p:nvPr>
+            <p:ph idx="2" type="sldImg"/>
+          </p:nvPr>
+        </p:nvSpPr>
+        <p:spPr>
+          <a:xfrm>
+            <a:off x="381300" y="685800"/>
+            <a:ext cx="6096000" cy="3429000"/>
+          </a:xfrm>
+          <a:custGeom>
+            <a:rect b="b" l="l" r="r" t="t"/>
+            <a:pathLst>
+              <a:path extrusionOk="0" h="120000" w="120000">
+                <a:moveTo>
+                  <a:pt x="0" y="0"/>
+                </a:moveTo>
+                <a:lnTo>
+                  <a:pt x="120000" y="0"/>
+                </a:lnTo>
+                <a:lnTo>
+                  <a:pt x="120000" y="120000"/>
+                </a:lnTo>
+                <a:lnTo>
+                  <a:pt x="0" y="120000"/>
+                </a:lnTo>
+                <a:close/>
+              </a:path>
+            </a:pathLst>
+          </a:custGeom>
+        </p:spPr>
+      </p:sp>
+      <p:sp>
+        <p:nvSpPr>
+          <p:cNvPr id="65" name="Google Shape;65;gb0586cafee_0_0:notes"/>
+          <p:cNvSpPr txBox="1"/>
+          <p:nvPr>
+            <p:ph idx="1" type="body"/>
+          </p:nvPr>
+        </p:nvSpPr>
+        <p:spPr>
+          <a:xfrm>
+            <a:off x="685800" y="4343400"/>
+            <a:ext cx="5486400" cy="4114800"/>
+          </a:xfrm>
+          <a:prstGeom prst="rect">
+            <a:avLst/>
+          </a:prstGeom>
+        </p:spPr>
+        <p:txBody>
+          <a:bodyPr anchorCtr="0" anchor="t" bIns="91425" lIns="91425" spcFirstLastPara="1" rIns="91425" wrap="square" tIns="91425">
+            <a:noAutofit/>
+          </a:bodyPr>
+          <a:lstStyle/>
+          <a:p>
+            <a:pPr indent="0" lvl="0" marL="0" rtl="0" algn="l">
+              <a:spcBef>
+                <a:spcPts val="0"/>
+              </a:spcBef>
+              <a:spcAft>
+                <a:spcPts val="0"/>
+              </a:spcAft>
+              <a:buNone/>
+            </a:pPr>
+            <a:r>
+              <a:t/>
+            </a:r>
+            <a:endParaRPr/>
+          </a:p>
+        </p:txBody>
+      </p:sp>
+    </p:spTree>
+  </p:cSld>
+  <p:clrMapOvr>
+    <a:masterClrMapping/>
+  </p:clrMapOvr>
+</p:notes>
+</file>
+
+<file path=ppt\notesSlides\notesSlide4.xml><?xml version="1.0" encoding="utf-8"?>
+<p:notes xmlns:a="http://schemas.openxmlformats.org/drawingml/2006/main" xmlns:r="http://schemas.openxmlformats.org/officeDocument/2006/relationships" xmlns:mc="http://schemas.openxmlformats.org/markup-compatibility/2006" xmlns:mv="urn:schemas-microsoft-com:mac:vml" xmlns:p="http://schemas.openxmlformats.org/presentationml/2006/main" xmlns:c="http://schemas.openxmlformats.org/drawingml/2006/chart" xmlns:dgm="http://schemas.openxmlformats.org/drawingml/2006/diagram" xmlns:o="urn:schemas-microsoft-com:office:office" xmlns:v="urn:schemas-microsoft-com:vml" xmlns:pvml="urn:schemas-microsoft-com:office:powerpoint" xmlns:com="http://schemas.openxmlformats.org/drawingml/2006/compatibility" xmlns:p14="http://schemas.microsoft.com/office/powerpoint/2010/main" xmlns:p15="http://schemas.microsoft.com/office/powerpoint/2012/main" xmlns:ahyp="http://schemas.microsoft.com/office/drawing/2018/hyperlinkcolor" showMasterPhAnim="0" showMasterSp="0">
+  <p:cSld>
+    <p:spTree>
+      <p:nvGrpSpPr>
+        <p:cNvPr id="69" name="Shape 69"/>
+        <p:cNvGrpSpPr/>
+        <p:nvPr/>
+      </p:nvGrpSpPr>
+      <p:grpSpPr>
+        <a:xfrm>
+          <a:off x="0" y="0"/>
+          <a:ext cx="0" cy="0"/>
+          <a:chOff x="0" y="0"/>
+          <a:chExt cx="0" cy="0"/>
+        </a:xfrm>
+      </p:grpSpPr>
+      <p:sp>
+        <p:nvSpPr>
+          <p:cNvPr id="70" name="Google Shape;70;gb0586cafee_0_8:notes"/>
+          <p:cNvSpPr/>
+          <p:nvPr>
+            <p:ph idx="2" type="sldImg"/>
+          </p:nvPr>
+        </p:nvSpPr>
+        <p:spPr>
+          <a:xfrm>
+            <a:off x="381300" y="685800"/>
+            <a:ext cx="6096000" cy="3429000"/>
+          </a:xfrm>
+          <a:custGeom>
+            <a:rect b="b" l="l" r="r" t="t"/>
+            <a:pathLst>
+              <a:path extrusionOk="0" h="120000" w="120000">
+                <a:moveTo>
+                  <a:pt x="0" y="0"/>
+                </a:moveTo>
+                <a:lnTo>
+                  <a:pt x="120000" y="0"/>
+                </a:lnTo>
+                <a:lnTo>
+                  <a:pt x="120000" y="120000"/>
+                </a:lnTo>
+                <a:lnTo>
+                  <a:pt x="0" y="120000"/>
+                </a:lnTo>
+                <a:close/>
+              </a:path>
+            </a:pathLst>
+          </a:custGeom>
+        </p:spPr>
+      </p:sp>
+      <p:sp>
+        <p:nvSpPr>
+          <p:cNvPr id="71" name="Google Shape;71;gb0586cafee_0_8:notes"/>
+          <p:cNvSpPr txBox="1"/>
+          <p:nvPr>
+            <p:ph idx="1" type="body"/>
+          </p:nvPr>
+        </p:nvSpPr>
+        <p:spPr>
+          <a:xfrm>
+            <a:off x="685800" y="4343400"/>
+            <a:ext cx="5486400" cy="4114800"/>
+          </a:xfrm>
+          <a:prstGeom prst="rect">
+            <a:avLst/>
+          </a:prstGeom>
+        </p:spPr>
+        <p:txBody>
+          <a:bodyPr anchorCtr="0" anchor="t" bIns="91425" lIns="91425" spcFirstLastPara="1" rIns="91425" wrap="square" tIns="91425">
+            <a:noAutofit/>
+          </a:bodyPr>
+          <a:lstStyle/>
+          <a:p>
+            <a:pPr indent="0" lvl="0" marL="0" rtl="0" algn="l">
+              <a:spcBef>
+                <a:spcPts val="0"/>
+              </a:spcBef>
+              <a:spcAft>
+                <a:spcPts val="0"/>
+              </a:spcAft>
+              <a:buNone/>
+            </a:pPr>
+            <a:r>
+              <a:t/>
+            </a:r>
+            <a:endParaRPr/>
+          </a:p>
+        </p:txBody>
+      </p:sp>
+    </p:spTree>
+  </p:cSld>
+  <p:clrMapOvr>
+    <a:masterClrMapping/>
+  </p:clrMapOvr>
+</p:notes>
+</file>
+
+<file path=ppt\notesSlides\notesSlide5.xml><?xml version="1.0" encoding="utf-8"?>
+<p:notes xmlns:a="http://schemas.openxmlformats.org/drawingml/2006/main" xmlns:r="http://schemas.openxmlformats.org/officeDocument/2006/relationships" xmlns:mc="http://schemas.openxmlformats.org/markup-compatibility/2006" xmlns:mv="urn:schemas-microsoft-com:mac:vml" xmlns:p="http://schemas.openxmlformats.org/presentationml/2006/main" xmlns:c="http://schemas.openxmlformats.org/drawingml/2006/chart" xmlns:dgm="http://schemas.openxmlformats.org/drawingml/2006/diagram" xmlns:o="urn:schemas-microsoft-com:office:office" xmlns:v="urn:schemas-microsoft-com:vml" xmlns:pvml="urn:schemas-microsoft-com:office:powerpoint" xmlns:com="http://schemas.openxmlformats.org/drawingml/2006/compatibility" xmlns:p14="http://schemas.microsoft.com/office/powerpoint/2010/main" xmlns:p15="http://schemas.microsoft.com/office/powerpoint/2012/main" xmlns:ahyp="http://schemas.microsoft.com/office/drawing/2018/hyperlinkcolor" showMasterPhAnim="0" showMasterSp="0">
+  <p:cSld>
+    <p:spTree>
+      <p:nvGrpSpPr>
+        <p:cNvPr id="76" name="Shape 76"/>
+        <p:cNvGrpSpPr/>
+        <p:nvPr/>
+      </p:nvGrpSpPr>
+      <p:grpSpPr>
+        <a:xfrm>
+          <a:off x="0" y="0"/>
+          <a:ext cx="0" cy="0"/>
+          <a:chOff x="0" y="0"/>
+          <a:chExt cx="0" cy="0"/>
+        </a:xfrm>
+      </p:grpSpPr>
+      <p:sp>
+        <p:nvSpPr>
+          <p:cNvPr id="77" name="Google Shape;77;gb0586cafee_0_14:notes"/>
+          <p:cNvSpPr/>
+          <p:nvPr>
+            <p:ph idx="2" type="sldImg"/>
+          </p:nvPr>
+        </p:nvSpPr>
+        <p:spPr>
+          <a:xfrm>
+            <a:off x="381300" y="685800"/>
+            <a:ext cx="6096000" cy="3429000"/>
+          </a:xfrm>
+          <a:custGeom>
+            <a:rect b="b" l="l" r="r" t="t"/>
+            <a:pathLst>
+              <a:path extrusionOk="0" h="120000" w="120000">
+                <a:moveTo>
+                  <a:pt x="0" y="0"/>
+                </a:moveTo>
+                <a:lnTo>
+                  <a:pt x="120000" y="0"/>
+                </a:lnTo>
+                <a:lnTo>
+                  <a:pt x="120000" y="120000"/>
+                </a:lnTo>
+                <a:lnTo>
+                  <a:pt x="0" y="120000"/>
+                </a:lnTo>
+                <a:close/>
+              </a:path>
+            </a:pathLst>
+          </a:custGeom>
+        </p:spPr>
+      </p:sp>
+      <p:sp>
+        <p:nvSpPr>
+          <p:cNvPr id="78" name="Google Shape;78;gb0586cafee_0_14:notes"/>
+          <p:cNvSpPr txBox="1"/>
+          <p:nvPr>
+            <p:ph idx="1" type="body"/>
+          </p:nvPr>
+        </p:nvSpPr>
+        <p:spPr>
+          <a:xfrm>
+            <a:off x="685800" y="4343400"/>
+            <a:ext cx="5486400" cy="4114800"/>
+          </a:xfrm>
+          <a:prstGeom prst="rect">
+            <a:avLst/>
+          </a:prstGeom>
+        </p:spPr>
+        <p:txBody>
+          <a:bodyPr anchorCtr="0" anchor="t" bIns="91425" lIns="91425" spcFirstLastPara="1" rIns="91425" wrap="square" tIns="91425">
+            <a:noAutofit/>
+          </a:bodyPr>
+          <a:lstStyle/>
+          <a:p>
+            <a:pPr indent="0" lvl="0" marL="0" rtl="0" algn="l">
+              <a:spcBef>
+                <a:spcPts val="0"/>
+              </a:spcBef>
+              <a:spcAft>
+                <a:spcPts val="0"/>
+              </a:spcAft>
+              <a:buNone/>
+            </a:pPr>
+            <a:r>
+              <a:t/>
+            </a:r>
+            <a:endParaRPr/>
+          </a:p>
+        </p:txBody>
+      </p:sp>
+    </p:spTree>
+  </p:cSld>
+  <p:clrMapOvr>
+    <a:masterClrMapping/>
+  </p:clrMapOvr>
+</p:notes>
+</file>
+
+<file path=ppt\notesSlides\notesSlide6.xml><?xml version="1.0" encoding="utf-8"?>
+<p:notes xmlns:a="http://schemas.openxmlformats.org/drawingml/2006/main" xmlns:r="http://schemas.openxmlformats.org/officeDocument/2006/relationships" xmlns:mc="http://schemas.openxmlformats.org/markup-compatibility/2006" xmlns:mv="urn:schemas-microsoft-com:mac:vml" xmlns:p="http://schemas.openxmlformats.org/presentationml/2006/main" xmlns:c="http://schemas.openxmlformats.org/drawingml/2006/chart" xmlns:dgm="http://schemas.openxmlformats.org/drawingml/2006/diagram" xmlns:o="urn:schemas-microsoft-com:office:office" xmlns:v="urn:schemas-microsoft-com:vml" xmlns:pvml="urn:schemas-microsoft-com:office:powerpoint" xmlns:com="http://schemas.openxmlformats.org/drawingml/2006/compatibility" xmlns:p14="http://schemas.microsoft.com/office/powerpoint/2010/main" xmlns:p15="http://schemas.microsoft.com/office/powerpoint/2012/main" xmlns:ahyp="http://schemas.microsoft.com/office/drawing/2018/hyperlinkcolor" showMasterPhAnim="0" showMasterSp="0">
+  <p:cSld>
+    <p:spTree>
+      <p:nvGrpSpPr>
+        <p:cNvPr id="83" name="Shape 83"/>
+        <p:cNvGrpSpPr/>
+        <p:nvPr/>
+      </p:nvGrpSpPr>
+      <p:grpSpPr>
+        <a:xfrm>
+          <a:off x="0" y="0"/>
+          <a:ext cx="0" cy="0"/>
+          <a:chOff x="0" y="0"/>
+          <a:chExt cx="0" cy="0"/>
+        </a:xfrm>
+      </p:grpSpPr>
+      <p:sp>
+        <p:nvSpPr>
+          <p:cNvPr id="84" name="Google Shape;84;gb0586cafee_0_22:notes"/>
+          <p:cNvSpPr/>
+          <p:nvPr>
+            <p:ph idx="2" type="sldImg"/>
+          </p:nvPr>
+        </p:nvSpPr>
+        <p:spPr>
+          <a:xfrm>
+            <a:off x="381300" y="685800"/>
+            <a:ext cx="6096000" cy="3429000"/>
+          </a:xfrm>
+          <a:custGeom>
+            <a:rect b="b" l="l" r="r" t="t"/>
+            <a:pathLst>
+              <a:path extrusionOk="0" h="120000" w="120000">
+                <a:moveTo>
+                  <a:pt x="0" y="0"/>
+                </a:moveTo>
+                <a:lnTo>
+                  <a:pt x="120000" y="0"/>
+                </a:lnTo>
+                <a:lnTo>
+                  <a:pt x="120000" y="120000"/>
+                </a:lnTo>
+                <a:lnTo>
+                  <a:pt x="0" y="120000"/>
+                </a:lnTo>
+                <a:close/>
+              </a:path>
+            </a:pathLst>
+          </a:custGeom>
+        </p:spPr>
+      </p:sp>
+      <p:sp>
+        <p:nvSpPr>
+          <p:cNvPr id="85" name="Google Shape;85;gb0586cafee_0_22:notes"/>
+          <p:cNvSpPr txBox="1"/>
+          <p:nvPr>
+            <p:ph idx="1" type="body"/>
+          </p:nvPr>
+        </p:nvSpPr>
+        <p:spPr>
+          <a:xfrm>
+            <a:off x="685800" y="4343400"/>
+            <a:ext cx="5486400" cy="4114800"/>
+          </a:xfrm>
+          <a:prstGeom prst="rect">
+            <a:avLst/>
+          </a:prstGeom>
+        </p:spPr>
+        <p:txBody>
+          <a:bodyPr anchorCtr="0" anchor="t" bIns="91425" lIns="91425" spcFirstLastPara="1" rIns="91425" wrap="square" tIns="91425">
+            <a:noAutofit/>
+          </a:bodyPr>
+          <a:lstStyle/>
+          <a:p>
+            <a:pPr indent="0" lvl="0" marL="0" rtl="0" algn="l">
+              <a:spcBef>
+                <a:spcPts val="0"/>
+              </a:spcBef>
+              <a:spcAft>
+                <a:spcPts val="0"/>
+              </a:spcAft>
+              <a:buNone/>
+            </a:pPr>
+            <a:r>
+              <a:t/>
+            </a:r>
+            <a:endParaRPr/>
+          </a:p>
+        </p:txBody>
+      </p:sp>
+    </p:spTree>
+  </p:cSld>
+  <p:clrMapOvr>
+    <a:masterClrMapping/>
+  </p:clrMapOvr>
+</p:notes>
+</file>
+
+<file path=ppt\notesSlides\notesSlide7.xml><?xml version="1.0" encoding="utf-8"?>
+<p:notes xmlns:a="http://schemas.openxmlformats.org/drawingml/2006/main" xmlns:r="http://schemas.openxmlformats.org/officeDocument/2006/relationships" xmlns:mc="http://schemas.openxmlformats.org/markup-compatibility/2006" xmlns:mv="urn:schemas-microsoft-com:mac:vml" xmlns:p="http://schemas.openxmlformats.org/presentationml/2006/main" xmlns:c="http://schemas.openxmlformats.org/drawingml/2006/chart" xmlns:dgm="http://schemas.openxmlformats.org/drawingml/2006/diagram" xmlns:o="urn:schemas-microsoft-com:office:office" xmlns:v="urn:schemas-microsoft-com:vml" xmlns:pvml="urn:schemas-microsoft-com:office:powerpoint" xmlns:com="http://schemas.openxmlformats.org/drawingml/2006/compatibility" xmlns:p14="http://schemas.microsoft.com/office/powerpoint/2010/main" xmlns:p15="http://schemas.microsoft.com/office/powerpoint/2012/main" xmlns:ahyp="http://schemas.microsoft.com/office/drawing/2018/hyperlinkcolor" showMasterPhAnim="0" showMasterSp="0">
+  <p:cSld>
+    <p:spTree>
+      <p:nvGrpSpPr>
+        <p:cNvPr id="89" name="Shape 89"/>
+        <p:cNvGrpSpPr/>
+        <p:nvPr/>
+      </p:nvGrpSpPr>
+      <p:grpSpPr>
+        <a:xfrm>
+          <a:off x="0" y="0"/>
+          <a:ext cx="0" cy="0"/>
+          <a:chOff x="0" y="0"/>
+          <a:chExt cx="0" cy="0"/>
+        </a:xfrm>
+      </p:grpSpPr>
+      <p:sp>
+        <p:nvSpPr>
+          <p:cNvPr id="90" name="Google Shape;90;gb0586cafee_0_27:notes"/>
+          <p:cNvSpPr/>
+          <p:nvPr>
+            <p:ph idx="2" type="sldImg"/>
+          </p:nvPr>
+        </p:nvSpPr>
+        <p:spPr>
+          <a:xfrm>
+            <a:off x="381300" y="685800"/>
+            <a:ext cx="6096000" cy="3429000"/>
+          </a:xfrm>
+          <a:custGeom>
+            <a:rect b="b" l="l" r="r" t="t"/>
+            <a:pathLst>
+              <a:path extrusionOk="0" h="120000" w="120000">
+                <a:moveTo>
+                  <a:pt x="0" y="0"/>
+                </a:moveTo>
+                <a:lnTo>
+                  <a:pt x="120000" y="0"/>
+                </a:lnTo>
+                <a:lnTo>
+                  <a:pt x="120000" y="120000"/>
+                </a:lnTo>
+                <a:lnTo>
+                  <a:pt x="0" y="120000"/>
+                </a:lnTo>
+                <a:close/>
+              </a:path>
+            </a:pathLst>
+          </a:custGeom>
+        </p:spPr>
+      </p:sp>
+      <p:sp>
+        <p:nvSpPr>
+          <p:cNvPr id="91" name="Google Shape;91;gb0586cafee_0_27:notes"/>
+          <p:cNvSpPr txBox="1"/>
+          <p:nvPr>
+            <p:ph idx="1" type="body"/>
+          </p:nvPr>
+        </p:nvSpPr>
+        <p:spPr>
+          <a:xfrm>
+            <a:off x="685800" y="4343400"/>
+            <a:ext cx="5486400" cy="4114800"/>
+          </a:xfrm>
+          <a:prstGeom prst="rect">
+            <a:avLst/>
+          </a:prstGeom>
+        </p:spPr>
+        <p:txBody>
+          <a:bodyPr anchorCtr="0" anchor="t" bIns="91425" lIns="91425" spcFirstLastPara="1" rIns="91425" wrap="square" tIns="91425">
+            <a:noAutofit/>
+          </a:bodyPr>
+          <a:lstStyle/>
+          <a:p>
+            <a:pPr indent="0" lvl="0" marL="0" rtl="0" algn="l">
+              <a:spcBef>
+                <a:spcPts val="0"/>
+              </a:spcBef>
+              <a:spcAft>
+                <a:spcPts val="0"/>
+              </a:spcAft>
+              <a:buNone/>
+            </a:pPr>
+            <a:r>
+              <a:t/>
+            </a:r>
+            <a:endParaRPr/>
+          </a:p>
+        </p:txBody>
+      </p:sp>
+    </p:spTree>
+  </p:cSld>
+  <p:clrMapOvr>
+    <a:masterClrMapping/>
+  </p:clrMapOvr>
+</p:notes>
+</file>
+
+<file path=ppt\notesSlides\notesSlide8.xml><?xml version="1.0" encoding="utf-8"?>
+<p:notes xmlns:a="http://schemas.openxmlformats.org/drawingml/2006/main" xmlns:r="http://schemas.openxmlformats.org/officeDocument/2006/relationships" xmlns:mc="http://schemas.openxmlformats.org/markup-compatibility/2006" xmlns:mv="urn:schemas-microsoft-com:mac:vml" xmlns:p="http://schemas.openxmlformats.org/presentationml/2006/main" xmlns:c="http://schemas.openxmlformats.org/drawingml/2006/chart" xmlns:dgm="http://schemas.openxmlformats.org/drawingml/2006/diagram" xmlns:o="urn:schemas-microsoft-com:office:office" xmlns:v="urn:schemas-microsoft-com:vml" xmlns:pvml="urn:schemas-microsoft-com:office:powerpoint" xmlns:com="http://schemas.openxmlformats.org/drawingml/2006/compatibility" xmlns:p14="http://schemas.microsoft.com/office/powerpoint/2010/main" xmlns:p15="http://schemas.microsoft.com/office/powerpoint/2012/main" xmlns:ahyp="http://schemas.microsoft.com/office/drawing/2018/hyperlinkcolor" showMasterPhAnim="0" showMasterSp="0">
+  <p:cSld>
+    <p:spTree>
+      <p:nvGrpSpPr>
+        <p:cNvPr id="95" name="Shape 95"/>
+        <p:cNvGrpSpPr/>
+        <p:nvPr/>
+      </p:nvGrpSpPr>
+      <p:grpSpPr>
+        <a:xfrm>
+          <a:off x="0" y="0"/>
+          <a:ext cx="0" cy="0"/>
+          <a:chOff x="0" y="0"/>
+          <a:chExt cx="0" cy="0"/>
+        </a:xfrm>
+      </p:grpSpPr>
+      <p:sp>
+        <p:nvSpPr>
+          <p:cNvPr id="96" name="Google Shape;96;gb0586cafee_0_32:notes"/>
+          <p:cNvSpPr/>
+          <p:nvPr>
+            <p:ph idx="2" type="sldImg"/>
+          </p:nvPr>
+        </p:nvSpPr>
+        <p:spPr>
+          <a:xfrm>
+            <a:off x="381300" y="685800"/>
+            <a:ext cx="6096000" cy="3429000"/>
+          </a:xfrm>
+          <a:custGeom>
+            <a:rect b="b" l="l" r="r" t="t"/>
+            <a:pathLst>
+              <a:path extrusionOk="0" h="120000" w="120000">
+                <a:moveTo>
+                  <a:pt x="0" y="0"/>
+                </a:moveTo>
+                <a:lnTo>
+                  <a:pt x="120000" y="0"/>
+                </a:lnTo>
+                <a:lnTo>
+                  <a:pt x="120000" y="120000"/>
+                </a:lnTo>
+                <a:lnTo>
+                  <a:pt x="0" y="120000"/>
+                </a:lnTo>
+                <a:close/>
+              </a:path>
+            </a:pathLst>
+          </a:custGeom>
+        </p:spPr>
+      </p:sp>
+      <p:sp>
+        <p:nvSpPr>
+          <p:cNvPr id="97" name="Google Shape;97;gb0586cafee_0_32:notes"/>
+          <p:cNvSpPr txBox="1"/>
+          <p:nvPr>
+            <p:ph idx="1" type="body"/>
+          </p:nvPr>
+        </p:nvSpPr>
+        <p:spPr>
+          <a:xfrm>
+            <a:off x="685800" y="4343400"/>
+            <a:ext cx="5486400" cy="4114800"/>
+          </a:xfrm>
+          <a:prstGeom prst="rect">
+            <a:avLst/>
+          </a:prstGeom>
+        </p:spPr>
+        <p:txBody>
+          <a:bodyPr anchorCtr="0" anchor="t" bIns="91425" lIns="91425" spcFirstLastPara="1" rIns="91425" wrap="square" tIns="91425">
+            <a:noAutofit/>
+          </a:bodyPr>
+          <a:lstStyle/>
+          <a:p>
+            <a:pPr indent="0" lvl="0" marL="0" rtl="0" algn="l">
+              <a:spcBef>
+                <a:spcPts val="0"/>
+              </a:spcBef>
+              <a:spcAft>
+                <a:spcPts val="0"/>
+              </a:spcAft>
+              <a:buNone/>
+            </a:pPr>
+            <a:r>
+              <a:t/>
+            </a:r>
+            <a:endParaRPr/>
+          </a:p>
+        </p:txBody>
+      </p:sp>
+    </p:spTree>
+  </p:cSld>
+  <p:clrMapOvr>
+    <a:masterClrMapping/>
+  </p:clrMapOvr>
+</p:notes>
+</file>
+
+<file path=ppt\notesSlides\notesSlide9.xml><?xml version="1.0" encoding="utf-8"?>
+<p:notes xmlns:a="http://schemas.openxmlformats.org/drawingml/2006/main" xmlns:r="http://schemas.openxmlformats.org/officeDocument/2006/relationships" xmlns:mc="http://schemas.openxmlformats.org/markup-compatibility/2006" xmlns:mv="urn:schemas-microsoft-com:mac:vml" xmlns:p="http://schemas.openxmlformats.org/presentationml/2006/main" xmlns:c="http://schemas.openxmlformats.org/drawingml/2006/chart" xmlns:dgm="http://schemas.openxmlformats.org/drawingml/2006/diagram" xmlns:o="urn:schemas-microsoft-com:office:office" xmlns:v="urn:schemas-microsoft-com:vml" xmlns:pvml="urn:schemas-microsoft-com:office:powerpoint" xmlns:com="http://schemas.openxmlformats.org/drawingml/2006/compatibility" xmlns:p14="http://schemas.microsoft.com/office/powerpoint/2010/main" xmlns:p15="http://schemas.microsoft.com/office/powerpoint/2012/main" xmlns:ahyp="http://schemas.microsoft.com/office/drawing/2018/hyperlinkcolor" showMasterPhAnim="0" showMasterSp="0">
+  <p:cSld>
+    <p:spTree>
+      <p:nvGrpSpPr>
+        <p:cNvPr id="102" name="Shape 102"/>
+        <p:cNvGrpSpPr/>
+        <p:nvPr/>
+      </p:nvGrpSpPr>
+      <p:grpSpPr>
+        <a:xfrm>
+          <a:off x="0" y="0"/>
+          <a:ext cx="0" cy="0"/>
+          <a:chOff x="0" y="0"/>
+          <a:chExt cx="0" cy="0"/>
+        </a:xfrm>
+      </p:grpSpPr>
+      <p:sp>
+        <p:nvSpPr>
+          <p:cNvPr id="103" name="Google Shape;103;gb0586cafee_0_41:notes"/>
+          <p:cNvSpPr/>
+          <p:nvPr>
+            <p:ph idx="2" type="sldImg"/>
+          </p:nvPr>
+        </p:nvSpPr>
+        <p:spPr>
+          <a:xfrm>
+            <a:off x="381300" y="685800"/>
+            <a:ext cx="6096000" cy="3429000"/>
+          </a:xfrm>
+          <a:custGeom>
+            <a:rect b="b" l="l" r="r" t="t"/>
+            <a:pathLst>
+              <a:path extrusionOk="0" h="120000" w="120000">
+                <a:moveTo>
+                  <a:pt x="0" y="0"/>
+                </a:moveTo>
+                <a:lnTo>
+                  <a:pt x="120000" y="0"/>
+                </a:lnTo>
+                <a:lnTo>
+                  <a:pt x="120000" y="120000"/>
+                </a:lnTo>
+                <a:lnTo>
+                  <a:pt x="0" y="120000"/>
+                </a:lnTo>
+                <a:close/>
+              </a:path>
+            </a:pathLst>
+          </a:custGeom>
+        </p:spPr>
+      </p:sp>
+      <p:sp>
+        <p:nvSpPr>
+          <p:cNvPr id="104" name="Google Shape;104;gb0586cafee_0_41:notes"/>
+          <p:cNvSpPr txBox="1"/>
+          <p:nvPr>
+            <p:ph idx="1" type="body"/>
+          </p:nvPr>
+        </p:nvSpPr>
+        <p:spPr>
+          <a:xfrm>
+            <a:off x="685800" y="4343400"/>
+            <a:ext cx="5486400" cy="4114800"/>
+          </a:xfrm>
+          <a:prstGeom prst="rect">
+            <a:avLst/>
+          </a:prstGeom>
+        </p:spPr>
+        <p:txBody>
+          <a:bodyPr anchorCtr="0" anchor="t" bIns="91425" lIns="91425" spcFirstLastPara="1" rIns="91425" wrap="square" tIns="91425">
+            <a:noAutofit/>
+          </a:bodyPr>
+          <a:lstStyle/>
+          <a:p>
+            <a:pPr indent="0" lvl="0" marL="0" rtl="0" algn="l">
+              <a:spcBef>
+                <a:spcPts val="0"/>
+              </a:spcBef>
+              <a:spcAft>
+                <a:spcPts val="0"/>
+              </a:spcAft>
+              <a:buNone/>
+            </a:pPr>
+            <a:r>
+              <a:t/>
+            </a:r>
+            <a:endParaRPr/>
+          </a:p>
+        </p:txBody>
+      </p:sp>
+    </p:spTree>
+  </p:cSld>
+  <p:clrMapOvr>
+    <a:masterClrMapping/>
+  </p:clrMapOvr>
+</p:notes>
+</file>
+
+<file path=ppt\presProps.xml><?xml version="1.0" encoding="utf-8"?>
+<p:presentationPr xmlns:a="http://schemas.openxmlformats.org/drawingml/2006/main" xmlns:r="http://schemas.openxmlformats.org/officeDocument/2006/relationships" xmlns:mc="http://schemas.openxmlformats.org/markup-compatibility/2006" xmlns:mv="urn:schemas-microsoft-com:mac:vml" xmlns:p="http://schemas.openxmlformats.org/presentationml/2006/main" xmlns:c="http://schemas.openxmlformats.org/drawingml/2006/chart" xmlns:dgm="http://schemas.openxmlformats.org/drawingml/2006/diagram" xmlns:o="urn:schemas-microsoft-com:office:office" xmlns:v="urn:schemas-microsoft-com:vml" xmlns:pvml="urn:schemas-microsoft-com:office:powerpoint" xmlns:com="http://schemas.openxmlformats.org/drawingml/2006/compatibility" xmlns:p14="http://schemas.microsoft.com/office/powerpoint/2010/main" xmlns:p15="http://schemas.microsoft.com/office/powerpoint/2012/main" xmlns:ahyp="http://schemas.microsoft.com/office/drawing/2018/hyperlinkcolor"/>
+</file>
+
+<file path=ppt\presentation.xml><?xml version="1.0" encoding="utf-8"?>
 <p:presentation xmlns:a="http://schemas.openxmlformats.org/drawingml/2006/main" xmlns:r="http://schemas.openxmlformats.org/officeDocument/2006/relationships" xmlns:mc="http://schemas.openxmlformats.org/markup-compatibility/2006" xmlns:mv="urn:schemas-microsoft-com:mac:vml" xmlns:p="http://schemas.openxmlformats.org/presentationml/2006/main" xmlns:c="http://schemas.openxmlformats.org/drawingml/2006/chart" xmlns:dgm="http://schemas.openxmlformats.org/drawingml/2006/diagram" xmlns:o="urn:schemas-microsoft-com:office:office" xmlns:v="urn:schemas-microsoft-com:vml" xmlns:pvml="urn:schemas-microsoft-com:office:powerpoint" xmlns:com="http://schemas.openxmlformats.org/drawingml/2006/compatibility" xmlns:p14="http://schemas.microsoft.com/office/powerpoint/2010/main" xmlns:p15="http://schemas.microsoft.com/office/powerpoint/2012/main" xmlns:ahyp="http://schemas.microsoft.com/office/drawing/2018/hyperlinkcolor" autoCompressPictures="0" strictFirstAndLastChars="0" saveSubsetFonts="1">
   <p:sldMasterIdLst>
     <p:sldMasterId id="2147483659" r:id="rId4"/>
@@ -272,1720 +1989,7 @@
 </p:presentation>
 </file>
 
-<file path=ppt/notesMasters/notesMaster1.xml><?xml version="1.0" encoding="utf-8"?>
-<p:notesMaster xmlns:a="http://schemas.openxmlformats.org/drawingml/2006/main" xmlns:r="http://schemas.openxmlformats.org/officeDocument/2006/relationships" xmlns:mc="http://schemas.openxmlformats.org/markup-compatibility/2006" xmlns:mv="urn:schemas-microsoft-com:mac:vml" xmlns:p="http://schemas.openxmlformats.org/presentationml/2006/main" xmlns:c="http://schemas.openxmlformats.org/drawingml/2006/chart" xmlns:dgm="http://schemas.openxmlformats.org/drawingml/2006/diagram" xmlns:o="urn:schemas-microsoft-com:office:office" xmlns:v="urn:schemas-microsoft-com:vml" xmlns:pvml="urn:schemas-microsoft-com:office:powerpoint" xmlns:com="http://schemas.openxmlformats.org/drawingml/2006/compatibility" xmlns:p14="http://schemas.microsoft.com/office/powerpoint/2010/main" xmlns:p15="http://schemas.microsoft.com/office/powerpoint/2012/main" xmlns:ahyp="http://schemas.microsoft.com/office/drawing/2018/hyperlinkcolor">
-  <p:cSld>
-    <p:spTree>
-      <p:nvGrpSpPr>
-        <p:cNvPr id="2" name="Shape 2"/>
-        <p:cNvGrpSpPr/>
-        <p:nvPr/>
-      </p:nvGrpSpPr>
-      <p:grpSpPr>
-        <a:xfrm>
-          <a:off x="0" y="0"/>
-          <a:ext cx="0" cy="0"/>
-          <a:chOff x="0" y="0"/>
-          <a:chExt cx="0" cy="0"/>
-        </a:xfrm>
-      </p:grpSpPr>
-      <p:sp>
-        <p:nvSpPr>
-          <p:cNvPr id="3" name="Google Shape;3;n"/>
-          <p:cNvSpPr/>
-          <p:nvPr>
-            <p:ph idx="2" type="sldImg"/>
-          </p:nvPr>
-        </p:nvSpPr>
-        <p:spPr>
-          <a:xfrm>
-            <a:off x="381300" y="685800"/>
-            <a:ext cx="6096075" cy="3429000"/>
-          </a:xfrm>
-          <a:custGeom>
-            <a:rect b="b" l="l" r="r" t="t"/>
-            <a:pathLst>
-              <a:path extrusionOk="0" h="120000" w="120000">
-                <a:moveTo>
-                  <a:pt x="0" y="0"/>
-                </a:moveTo>
-                <a:lnTo>
-                  <a:pt x="120000" y="0"/>
-                </a:lnTo>
-                <a:lnTo>
-                  <a:pt x="120000" y="120000"/>
-                </a:lnTo>
-                <a:lnTo>
-                  <a:pt x="0" y="120000"/>
-                </a:lnTo>
-                <a:close/>
-              </a:path>
-            </a:pathLst>
-          </a:custGeom>
-          <a:noFill/>
-          <a:ln cap="flat" cmpd="sng" w="9525">
-            <a:solidFill>
-              <a:srgbClr val="000000"/>
-            </a:solidFill>
-            <a:prstDash val="solid"/>
-            <a:round/>
-            <a:headEnd len="sm" w="sm" type="none"/>
-            <a:tailEnd len="sm" w="sm" type="none"/>
-          </a:ln>
-        </p:spPr>
-      </p:sp>
-      <p:sp>
-        <p:nvSpPr>
-          <p:cNvPr id="4" name="Google Shape;4;n"/>
-          <p:cNvSpPr txBox="1"/>
-          <p:nvPr>
-            <p:ph idx="1" type="body"/>
-          </p:nvPr>
-        </p:nvSpPr>
-        <p:spPr>
-          <a:xfrm>
-            <a:off x="685800" y="4343400"/>
-            <a:ext cx="5486400" cy="4114800"/>
-          </a:xfrm>
-          <a:prstGeom prst="rect">
-            <a:avLst/>
-          </a:prstGeom>
-          <a:noFill/>
-          <a:ln>
-            <a:noFill/>
-          </a:ln>
-        </p:spPr>
-        <p:txBody>
-          <a:bodyPr anchorCtr="0" anchor="t" bIns="91425" lIns="91425" spcFirstLastPara="1" rIns="91425" wrap="square" tIns="91425">
-            <a:noAutofit/>
-          </a:bodyPr>
-          <a:lstStyle>
-            <a:lvl1pPr indent="-298450" lvl="0" marL="457200">
-              <a:spcBef>
-                <a:spcPts val="0"/>
-              </a:spcBef>
-              <a:spcAft>
-                <a:spcPts val="0"/>
-              </a:spcAft>
-              <a:buSzPts val="1100"/>
-              <a:buChar char="●"/>
-              <a:defRPr sz="1100"/>
-            </a:lvl1pPr>
-            <a:lvl2pPr indent="-298450" lvl="1" marL="914400">
-              <a:spcBef>
-                <a:spcPts val="0"/>
-              </a:spcBef>
-              <a:spcAft>
-                <a:spcPts val="0"/>
-              </a:spcAft>
-              <a:buSzPts val="1100"/>
-              <a:buChar char="○"/>
-              <a:defRPr sz="1100"/>
-            </a:lvl2pPr>
-            <a:lvl3pPr indent="-298450" lvl="2" marL="1371600">
-              <a:spcBef>
-                <a:spcPts val="0"/>
-              </a:spcBef>
-              <a:spcAft>
-                <a:spcPts val="0"/>
-              </a:spcAft>
-              <a:buSzPts val="1100"/>
-              <a:buChar char="■"/>
-              <a:defRPr sz="1100"/>
-            </a:lvl3pPr>
-            <a:lvl4pPr indent="-298450" lvl="3" marL="1828800">
-              <a:spcBef>
-                <a:spcPts val="0"/>
-              </a:spcBef>
-              <a:spcAft>
-                <a:spcPts val="0"/>
-              </a:spcAft>
-              <a:buSzPts val="1100"/>
-              <a:buChar char="●"/>
-              <a:defRPr sz="1100"/>
-            </a:lvl4pPr>
-            <a:lvl5pPr indent="-298450" lvl="4" marL="2286000">
-              <a:spcBef>
-                <a:spcPts val="0"/>
-              </a:spcBef>
-              <a:spcAft>
-                <a:spcPts val="0"/>
-              </a:spcAft>
-              <a:buSzPts val="1100"/>
-              <a:buChar char="○"/>
-              <a:defRPr sz="1100"/>
-            </a:lvl5pPr>
-            <a:lvl6pPr indent="-298450" lvl="5" marL="2743200">
-              <a:spcBef>
-                <a:spcPts val="0"/>
-              </a:spcBef>
-              <a:spcAft>
-                <a:spcPts val="0"/>
-              </a:spcAft>
-              <a:buSzPts val="1100"/>
-              <a:buChar char="■"/>
-              <a:defRPr sz="1100"/>
-            </a:lvl6pPr>
-            <a:lvl7pPr indent="-298450" lvl="6" marL="3200400">
-              <a:spcBef>
-                <a:spcPts val="0"/>
-              </a:spcBef>
-              <a:spcAft>
-                <a:spcPts val="0"/>
-              </a:spcAft>
-              <a:buSzPts val="1100"/>
-              <a:buChar char="●"/>
-              <a:defRPr sz="1100"/>
-            </a:lvl7pPr>
-            <a:lvl8pPr indent="-298450" lvl="7" marL="3657600">
-              <a:spcBef>
-                <a:spcPts val="0"/>
-              </a:spcBef>
-              <a:spcAft>
-                <a:spcPts val="0"/>
-              </a:spcAft>
-              <a:buSzPts val="1100"/>
-              <a:buChar char="○"/>
-              <a:defRPr sz="1100"/>
-            </a:lvl8pPr>
-            <a:lvl9pPr indent="-298450" lvl="8" marL="4114800">
-              <a:spcBef>
-                <a:spcPts val="0"/>
-              </a:spcBef>
-              <a:spcAft>
-                <a:spcPts val="0"/>
-              </a:spcAft>
-              <a:buSzPts val="1100"/>
-              <a:buChar char="■"/>
-              <a:defRPr sz="1100"/>
-            </a:lvl9pPr>
-          </a:lstStyle>
-          <a:p/>
-        </p:txBody>
-      </p:sp>
-    </p:spTree>
-  </p:cSld>
-  <p:clrMap accent1="accent1" accent2="accent2" accent3="accent3" accent4="accent4" accent5="accent5" accent6="accent6" bg1="lt1" bg2="dk2" tx1="dk1" tx2="lt2" folHlink="folHlink" hlink="hlink"/>
-  <p:notesStyle>
-    <a:defPPr lvl="0" marR="0" rtl="0" algn="l">
-      <a:lnSpc>
-        <a:spcPct val="100000"/>
-      </a:lnSpc>
-      <a:spcBef>
-        <a:spcPts val="0"/>
-      </a:spcBef>
-      <a:spcAft>
-        <a:spcPts val="0"/>
-      </a:spcAft>
-    </a:defPPr>
-    <a:lvl1pPr lvl="0" marR="0" rtl="0" algn="l">
-      <a:lnSpc>
-        <a:spcPct val="100000"/>
-      </a:lnSpc>
-      <a:spcBef>
-        <a:spcPts val="0"/>
-      </a:spcBef>
-      <a:spcAft>
-        <a:spcPts val="0"/>
-      </a:spcAft>
-      <a:buClr>
-        <a:srgbClr val="000000"/>
-      </a:buClr>
-      <a:buFont typeface="Arial"/>
-      <a:defRPr b="0" i="0" sz="1400" u="none" cap="none" strike="noStrike">
-        <a:solidFill>
-          <a:srgbClr val="000000"/>
-        </a:solidFill>
-        <a:latin typeface="Arial"/>
-        <a:ea typeface="Arial"/>
-        <a:cs typeface="Arial"/>
-        <a:sym typeface="Arial"/>
-      </a:defRPr>
-    </a:lvl1pPr>
-    <a:lvl2pPr lvl="1" marR="0" rtl="0" algn="l">
-      <a:lnSpc>
-        <a:spcPct val="100000"/>
-      </a:lnSpc>
-      <a:spcBef>
-        <a:spcPts val="0"/>
-      </a:spcBef>
-      <a:spcAft>
-        <a:spcPts val="0"/>
-      </a:spcAft>
-      <a:buClr>
-        <a:srgbClr val="000000"/>
-      </a:buClr>
-      <a:buFont typeface="Arial"/>
-      <a:defRPr b="0" i="0" sz="1400" u="none" cap="none" strike="noStrike">
-        <a:solidFill>
-          <a:srgbClr val="000000"/>
-        </a:solidFill>
-        <a:latin typeface="Arial"/>
-        <a:ea typeface="Arial"/>
-        <a:cs typeface="Arial"/>
-        <a:sym typeface="Arial"/>
-      </a:defRPr>
-    </a:lvl2pPr>
-    <a:lvl3pPr lvl="2" marR="0" rtl="0" algn="l">
-      <a:lnSpc>
-        <a:spcPct val="100000"/>
-      </a:lnSpc>
-      <a:spcBef>
-        <a:spcPts val="0"/>
-      </a:spcBef>
-      <a:spcAft>
-        <a:spcPts val="0"/>
-      </a:spcAft>
-      <a:buClr>
-        <a:srgbClr val="000000"/>
-      </a:buClr>
-      <a:buFont typeface="Arial"/>
-      <a:defRPr b="0" i="0" sz="1400" u="none" cap="none" strike="noStrike">
-        <a:solidFill>
-          <a:srgbClr val="000000"/>
-        </a:solidFill>
-        <a:latin typeface="Arial"/>
-        <a:ea typeface="Arial"/>
-        <a:cs typeface="Arial"/>
-        <a:sym typeface="Arial"/>
-      </a:defRPr>
-    </a:lvl3pPr>
-    <a:lvl4pPr lvl="3" marR="0" rtl="0" algn="l">
-      <a:lnSpc>
-        <a:spcPct val="100000"/>
-      </a:lnSpc>
-      <a:spcBef>
-        <a:spcPts val="0"/>
-      </a:spcBef>
-      <a:spcAft>
-        <a:spcPts val="0"/>
-      </a:spcAft>
-      <a:buClr>
-        <a:srgbClr val="000000"/>
-      </a:buClr>
-      <a:buFont typeface="Arial"/>
-      <a:defRPr b="0" i="0" sz="1400" u="none" cap="none" strike="noStrike">
-        <a:solidFill>
-          <a:srgbClr val="000000"/>
-        </a:solidFill>
-        <a:latin typeface="Arial"/>
-        <a:ea typeface="Arial"/>
-        <a:cs typeface="Arial"/>
-        <a:sym typeface="Arial"/>
-      </a:defRPr>
-    </a:lvl4pPr>
-    <a:lvl5pPr lvl="4" marR="0" rtl="0" algn="l">
-      <a:lnSpc>
-        <a:spcPct val="100000"/>
-      </a:lnSpc>
-      <a:spcBef>
-        <a:spcPts val="0"/>
-      </a:spcBef>
-      <a:spcAft>
-        <a:spcPts val="0"/>
-      </a:spcAft>
-      <a:buClr>
-        <a:srgbClr val="000000"/>
-      </a:buClr>
-      <a:buFont typeface="Arial"/>
-      <a:defRPr b="0" i="0" sz="1400" u="none" cap="none" strike="noStrike">
-        <a:solidFill>
-          <a:srgbClr val="000000"/>
-        </a:solidFill>
-        <a:latin typeface="Arial"/>
-        <a:ea typeface="Arial"/>
-        <a:cs typeface="Arial"/>
-        <a:sym typeface="Arial"/>
-      </a:defRPr>
-    </a:lvl5pPr>
-    <a:lvl6pPr lvl="5" marR="0" rtl="0" algn="l">
-      <a:lnSpc>
-        <a:spcPct val="100000"/>
-      </a:lnSpc>
-      <a:spcBef>
-        <a:spcPts val="0"/>
-      </a:spcBef>
-      <a:spcAft>
-        <a:spcPts val="0"/>
-      </a:spcAft>
-      <a:buClr>
-        <a:srgbClr val="000000"/>
-      </a:buClr>
-      <a:buFont typeface="Arial"/>
-      <a:defRPr b="0" i="0" sz="1400" u="none" cap="none" strike="noStrike">
-        <a:solidFill>
-          <a:srgbClr val="000000"/>
-        </a:solidFill>
-        <a:latin typeface="Arial"/>
-        <a:ea typeface="Arial"/>
-        <a:cs typeface="Arial"/>
-        <a:sym typeface="Arial"/>
-      </a:defRPr>
-    </a:lvl6pPr>
-    <a:lvl7pPr lvl="6" marR="0" rtl="0" algn="l">
-      <a:lnSpc>
-        <a:spcPct val="100000"/>
-      </a:lnSpc>
-      <a:spcBef>
-        <a:spcPts val="0"/>
-      </a:spcBef>
-      <a:spcAft>
-        <a:spcPts val="0"/>
-      </a:spcAft>
-      <a:buClr>
-        <a:srgbClr val="000000"/>
-      </a:buClr>
-      <a:buFont typeface="Arial"/>
-      <a:defRPr b="0" i="0" sz="1400" u="none" cap="none" strike="noStrike">
-        <a:solidFill>
-          <a:srgbClr val="000000"/>
-        </a:solidFill>
-        <a:latin typeface="Arial"/>
-        <a:ea typeface="Arial"/>
-        <a:cs typeface="Arial"/>
-        <a:sym typeface="Arial"/>
-      </a:defRPr>
-    </a:lvl7pPr>
-    <a:lvl8pPr lvl="7" marR="0" rtl="0" algn="l">
-      <a:lnSpc>
-        <a:spcPct val="100000"/>
-      </a:lnSpc>
-      <a:spcBef>
-        <a:spcPts val="0"/>
-      </a:spcBef>
-      <a:spcAft>
-        <a:spcPts val="0"/>
-      </a:spcAft>
-      <a:buClr>
-        <a:srgbClr val="000000"/>
-      </a:buClr>
-      <a:buFont typeface="Arial"/>
-      <a:defRPr b="0" i="0" sz="1400" u="none" cap="none" strike="noStrike">
-        <a:solidFill>
-          <a:srgbClr val="000000"/>
-        </a:solidFill>
-        <a:latin typeface="Arial"/>
-        <a:ea typeface="Arial"/>
-        <a:cs typeface="Arial"/>
-        <a:sym typeface="Arial"/>
-      </a:defRPr>
-    </a:lvl8pPr>
-    <a:lvl9pPr lvl="8" marR="0" rtl="0" algn="l">
-      <a:lnSpc>
-        <a:spcPct val="100000"/>
-      </a:lnSpc>
-      <a:spcBef>
-        <a:spcPts val="0"/>
-      </a:spcBef>
-      <a:spcAft>
-        <a:spcPts val="0"/>
-      </a:spcAft>
-      <a:buClr>
-        <a:srgbClr val="000000"/>
-      </a:buClr>
-      <a:buFont typeface="Arial"/>
-      <a:defRPr b="0" i="0" sz="1400" u="none" cap="none" strike="noStrike">
-        <a:solidFill>
-          <a:srgbClr val="000000"/>
-        </a:solidFill>
-        <a:latin typeface="Arial"/>
-        <a:ea typeface="Arial"/>
-        <a:cs typeface="Arial"/>
-        <a:sym typeface="Arial"/>
-      </a:defRPr>
-    </a:lvl9pPr>
-  </p:notesStyle>
-</p:notesMaster>
-</file>
-
-<file path=ppt/notesSlides/notesSlide1.xml><?xml version="1.0" encoding="utf-8"?>
-<p:notes xmlns:a="http://schemas.openxmlformats.org/drawingml/2006/main" xmlns:r="http://schemas.openxmlformats.org/officeDocument/2006/relationships" xmlns:mc="http://schemas.openxmlformats.org/markup-compatibility/2006" xmlns:mv="urn:schemas-microsoft-com:mac:vml" xmlns:p="http://schemas.openxmlformats.org/presentationml/2006/main" xmlns:c="http://schemas.openxmlformats.org/drawingml/2006/chart" xmlns:dgm="http://schemas.openxmlformats.org/drawingml/2006/diagram" xmlns:o="urn:schemas-microsoft-com:office:office" xmlns:v="urn:schemas-microsoft-com:vml" xmlns:pvml="urn:schemas-microsoft-com:office:powerpoint" xmlns:com="http://schemas.openxmlformats.org/drawingml/2006/compatibility" xmlns:p14="http://schemas.microsoft.com/office/powerpoint/2010/main" xmlns:p15="http://schemas.microsoft.com/office/powerpoint/2012/main" xmlns:ahyp="http://schemas.microsoft.com/office/drawing/2018/hyperlinkcolor" showMasterPhAnim="0" showMasterSp="0">
-  <p:cSld>
-    <p:spTree>
-      <p:nvGrpSpPr>
-        <p:cNvPr id="50" name="Shape 50"/>
-        <p:cNvGrpSpPr/>
-        <p:nvPr/>
-      </p:nvGrpSpPr>
-      <p:grpSpPr>
-        <a:xfrm>
-          <a:off x="0" y="0"/>
-          <a:ext cx="0" cy="0"/>
-          <a:chOff x="0" y="0"/>
-          <a:chExt cx="0" cy="0"/>
-        </a:xfrm>
-      </p:grpSpPr>
-      <p:sp>
-        <p:nvSpPr>
-          <p:cNvPr id="51" name="Google Shape;51;p:notes"/>
-          <p:cNvSpPr/>
-          <p:nvPr>
-            <p:ph idx="2" type="sldImg"/>
-          </p:nvPr>
-        </p:nvSpPr>
-        <p:spPr>
-          <a:xfrm>
-            <a:off x="381300" y="685800"/>
-            <a:ext cx="6096075" cy="3429000"/>
-          </a:xfrm>
-          <a:custGeom>
-            <a:rect b="b" l="l" r="r" t="t"/>
-            <a:pathLst>
-              <a:path extrusionOk="0" h="120000" w="120000">
-                <a:moveTo>
-                  <a:pt x="0" y="0"/>
-                </a:moveTo>
-                <a:lnTo>
-                  <a:pt x="120000" y="0"/>
-                </a:lnTo>
-                <a:lnTo>
-                  <a:pt x="120000" y="120000"/>
-                </a:lnTo>
-                <a:lnTo>
-                  <a:pt x="0" y="120000"/>
-                </a:lnTo>
-                <a:close/>
-              </a:path>
-            </a:pathLst>
-          </a:custGeom>
-        </p:spPr>
-      </p:sp>
-      <p:sp>
-        <p:nvSpPr>
-          <p:cNvPr id="52" name="Google Shape;52;p:notes"/>
-          <p:cNvSpPr txBox="1"/>
-          <p:nvPr>
-            <p:ph idx="1" type="body"/>
-          </p:nvPr>
-        </p:nvSpPr>
-        <p:spPr>
-          <a:xfrm>
-            <a:off x="685800" y="4343400"/>
-            <a:ext cx="5486400" cy="4114800"/>
-          </a:xfrm>
-          <a:prstGeom prst="rect">
-            <a:avLst/>
-          </a:prstGeom>
-        </p:spPr>
-        <p:txBody>
-          <a:bodyPr anchorCtr="0" anchor="t" bIns="91425" lIns="91425" spcFirstLastPara="1" rIns="91425" wrap="square" tIns="91425">
-            <a:noAutofit/>
-          </a:bodyPr>
-          <a:lstStyle/>
-          <a:p>
-            <a:pPr indent="0" lvl="0" marL="0" rtl="0" algn="l">
-              <a:spcBef>
-                <a:spcPts val="0"/>
-              </a:spcBef>
-              <a:spcAft>
-                <a:spcPts val="0"/>
-              </a:spcAft>
-              <a:buNone/>
-            </a:pPr>
-            <a:r>
-              <a:t/>
-            </a:r>
-            <a:endParaRPr/>
-          </a:p>
-        </p:txBody>
-      </p:sp>
-    </p:spTree>
-  </p:cSld>
-  <p:clrMapOvr>
-    <a:masterClrMapping/>
-  </p:clrMapOvr>
-</p:notes>
-</file>
-
-<file path=ppt/notesSlides/notesSlide10.xml><?xml version="1.0" encoding="utf-8"?>
-<p:notes xmlns:a="http://schemas.openxmlformats.org/drawingml/2006/main" xmlns:r="http://schemas.openxmlformats.org/officeDocument/2006/relationships" xmlns:mc="http://schemas.openxmlformats.org/markup-compatibility/2006" xmlns:mv="urn:schemas-microsoft-com:mac:vml" xmlns:p="http://schemas.openxmlformats.org/presentationml/2006/main" xmlns:c="http://schemas.openxmlformats.org/drawingml/2006/chart" xmlns:dgm="http://schemas.openxmlformats.org/drawingml/2006/diagram" xmlns:o="urn:schemas-microsoft-com:office:office" xmlns:v="urn:schemas-microsoft-com:vml" xmlns:pvml="urn:schemas-microsoft-com:office:powerpoint" xmlns:com="http://schemas.openxmlformats.org/drawingml/2006/compatibility" xmlns:p14="http://schemas.microsoft.com/office/powerpoint/2010/main" xmlns:p15="http://schemas.microsoft.com/office/powerpoint/2012/main" xmlns:ahyp="http://schemas.microsoft.com/office/drawing/2018/hyperlinkcolor" showMasterPhAnim="0" showMasterSp="0">
-  <p:cSld>
-    <p:spTree>
-      <p:nvGrpSpPr>
-        <p:cNvPr id="108" name="Shape 108"/>
-        <p:cNvGrpSpPr/>
-        <p:nvPr/>
-      </p:nvGrpSpPr>
-      <p:grpSpPr>
-        <a:xfrm>
-          <a:off x="0" y="0"/>
-          <a:ext cx="0" cy="0"/>
-          <a:chOff x="0" y="0"/>
-          <a:chExt cx="0" cy="0"/>
-        </a:xfrm>
-      </p:grpSpPr>
-      <p:sp>
-        <p:nvSpPr>
-          <p:cNvPr id="109" name="Google Shape;109;gb0586cafee_0_49:notes"/>
-          <p:cNvSpPr/>
-          <p:nvPr>
-            <p:ph idx="2" type="sldImg"/>
-          </p:nvPr>
-        </p:nvSpPr>
-        <p:spPr>
-          <a:xfrm>
-            <a:off x="381300" y="685800"/>
-            <a:ext cx="6096000" cy="3429000"/>
-          </a:xfrm>
-          <a:custGeom>
-            <a:rect b="b" l="l" r="r" t="t"/>
-            <a:pathLst>
-              <a:path extrusionOk="0" h="120000" w="120000">
-                <a:moveTo>
-                  <a:pt x="0" y="0"/>
-                </a:moveTo>
-                <a:lnTo>
-                  <a:pt x="120000" y="0"/>
-                </a:lnTo>
-                <a:lnTo>
-                  <a:pt x="120000" y="120000"/>
-                </a:lnTo>
-                <a:lnTo>
-                  <a:pt x="0" y="120000"/>
-                </a:lnTo>
-                <a:close/>
-              </a:path>
-            </a:pathLst>
-          </a:custGeom>
-        </p:spPr>
-      </p:sp>
-      <p:sp>
-        <p:nvSpPr>
-          <p:cNvPr id="110" name="Google Shape;110;gb0586cafee_0_49:notes"/>
-          <p:cNvSpPr txBox="1"/>
-          <p:nvPr>
-            <p:ph idx="1" type="body"/>
-          </p:nvPr>
-        </p:nvSpPr>
-        <p:spPr>
-          <a:xfrm>
-            <a:off x="685800" y="4343400"/>
-            <a:ext cx="5486400" cy="4114800"/>
-          </a:xfrm>
-          <a:prstGeom prst="rect">
-            <a:avLst/>
-          </a:prstGeom>
-        </p:spPr>
-        <p:txBody>
-          <a:bodyPr anchorCtr="0" anchor="t" bIns="91425" lIns="91425" spcFirstLastPara="1" rIns="91425" wrap="square" tIns="91425">
-            <a:noAutofit/>
-          </a:bodyPr>
-          <a:lstStyle/>
-          <a:p>
-            <a:pPr indent="0" lvl="0" marL="0" rtl="0" algn="l">
-              <a:spcBef>
-                <a:spcPts val="0"/>
-              </a:spcBef>
-              <a:spcAft>
-                <a:spcPts val="0"/>
-              </a:spcAft>
-              <a:buNone/>
-            </a:pPr>
-            <a:r>
-              <a:t/>
-            </a:r>
-            <a:endParaRPr/>
-          </a:p>
-        </p:txBody>
-      </p:sp>
-    </p:spTree>
-  </p:cSld>
-  <p:clrMapOvr>
-    <a:masterClrMapping/>
-  </p:clrMapOvr>
-</p:notes>
-</file>
-
-<file path=ppt/notesSlides/notesSlide11.xml><?xml version="1.0" encoding="utf-8"?>
-<p:notes xmlns:a="http://schemas.openxmlformats.org/drawingml/2006/main" xmlns:r="http://schemas.openxmlformats.org/officeDocument/2006/relationships" xmlns:mc="http://schemas.openxmlformats.org/markup-compatibility/2006" xmlns:mv="urn:schemas-microsoft-com:mac:vml" xmlns:p="http://schemas.openxmlformats.org/presentationml/2006/main" xmlns:c="http://schemas.openxmlformats.org/drawingml/2006/chart" xmlns:dgm="http://schemas.openxmlformats.org/drawingml/2006/diagram" xmlns:o="urn:schemas-microsoft-com:office:office" xmlns:v="urn:schemas-microsoft-com:vml" xmlns:pvml="urn:schemas-microsoft-com:office:powerpoint" xmlns:com="http://schemas.openxmlformats.org/drawingml/2006/compatibility" xmlns:p14="http://schemas.microsoft.com/office/powerpoint/2010/main" xmlns:p15="http://schemas.microsoft.com/office/powerpoint/2012/main" xmlns:ahyp="http://schemas.microsoft.com/office/drawing/2018/hyperlinkcolor" showMasterPhAnim="0" showMasterSp="0">
-  <p:cSld>
-    <p:spTree>
-      <p:nvGrpSpPr>
-        <p:cNvPr id="115" name="Shape 115"/>
-        <p:cNvGrpSpPr/>
-        <p:nvPr/>
-      </p:nvGrpSpPr>
-      <p:grpSpPr>
-        <a:xfrm>
-          <a:off x="0" y="0"/>
-          <a:ext cx="0" cy="0"/>
-          <a:chOff x="0" y="0"/>
-          <a:chExt cx="0" cy="0"/>
-        </a:xfrm>
-      </p:grpSpPr>
-      <p:sp>
-        <p:nvSpPr>
-          <p:cNvPr id="116" name="Google Shape;116;gb0586cafee_0_55:notes"/>
-          <p:cNvSpPr/>
-          <p:nvPr>
-            <p:ph idx="2" type="sldImg"/>
-          </p:nvPr>
-        </p:nvSpPr>
-        <p:spPr>
-          <a:xfrm>
-            <a:off x="381300" y="685800"/>
-            <a:ext cx="6096000" cy="3429000"/>
-          </a:xfrm>
-          <a:custGeom>
-            <a:rect b="b" l="l" r="r" t="t"/>
-            <a:pathLst>
-              <a:path extrusionOk="0" h="120000" w="120000">
-                <a:moveTo>
-                  <a:pt x="0" y="0"/>
-                </a:moveTo>
-                <a:lnTo>
-                  <a:pt x="120000" y="0"/>
-                </a:lnTo>
-                <a:lnTo>
-                  <a:pt x="120000" y="120000"/>
-                </a:lnTo>
-                <a:lnTo>
-                  <a:pt x="0" y="120000"/>
-                </a:lnTo>
-                <a:close/>
-              </a:path>
-            </a:pathLst>
-          </a:custGeom>
-        </p:spPr>
-      </p:sp>
-      <p:sp>
-        <p:nvSpPr>
-          <p:cNvPr id="117" name="Google Shape;117;gb0586cafee_0_55:notes"/>
-          <p:cNvSpPr txBox="1"/>
-          <p:nvPr>
-            <p:ph idx="1" type="body"/>
-          </p:nvPr>
-        </p:nvSpPr>
-        <p:spPr>
-          <a:xfrm>
-            <a:off x="685800" y="4343400"/>
-            <a:ext cx="5486400" cy="4114800"/>
-          </a:xfrm>
-          <a:prstGeom prst="rect">
-            <a:avLst/>
-          </a:prstGeom>
-        </p:spPr>
-        <p:txBody>
-          <a:bodyPr anchorCtr="0" anchor="t" bIns="91425" lIns="91425" spcFirstLastPara="1" rIns="91425" wrap="square" tIns="91425">
-            <a:noAutofit/>
-          </a:bodyPr>
-          <a:lstStyle/>
-          <a:p>
-            <a:pPr indent="0" lvl="0" marL="0" rtl="0" algn="l">
-              <a:spcBef>
-                <a:spcPts val="0"/>
-              </a:spcBef>
-              <a:spcAft>
-                <a:spcPts val="0"/>
-              </a:spcAft>
-              <a:buNone/>
-            </a:pPr>
-            <a:r>
-              <a:t/>
-            </a:r>
-            <a:endParaRPr/>
-          </a:p>
-        </p:txBody>
-      </p:sp>
-    </p:spTree>
-  </p:cSld>
-  <p:clrMapOvr>
-    <a:masterClrMapping/>
-  </p:clrMapOvr>
-</p:notes>
-</file>
-
-<file path=ppt/notesSlides/notesSlide12.xml><?xml version="1.0" encoding="utf-8"?>
-<p:notes xmlns:a="http://schemas.openxmlformats.org/drawingml/2006/main" xmlns:r="http://schemas.openxmlformats.org/officeDocument/2006/relationships" xmlns:mc="http://schemas.openxmlformats.org/markup-compatibility/2006" xmlns:mv="urn:schemas-microsoft-com:mac:vml" xmlns:p="http://schemas.openxmlformats.org/presentationml/2006/main" xmlns:c="http://schemas.openxmlformats.org/drawingml/2006/chart" xmlns:dgm="http://schemas.openxmlformats.org/drawingml/2006/diagram" xmlns:o="urn:schemas-microsoft-com:office:office" xmlns:v="urn:schemas-microsoft-com:vml" xmlns:pvml="urn:schemas-microsoft-com:office:powerpoint" xmlns:com="http://schemas.openxmlformats.org/drawingml/2006/compatibility" xmlns:p14="http://schemas.microsoft.com/office/powerpoint/2010/main" xmlns:p15="http://schemas.microsoft.com/office/powerpoint/2012/main" xmlns:ahyp="http://schemas.microsoft.com/office/drawing/2018/hyperlinkcolor" showMasterPhAnim="0" showMasterSp="0">
-  <p:cSld>
-    <p:spTree>
-      <p:nvGrpSpPr>
-        <p:cNvPr id="121" name="Shape 121"/>
-        <p:cNvGrpSpPr/>
-        <p:nvPr/>
-      </p:nvGrpSpPr>
-      <p:grpSpPr>
-        <a:xfrm>
-          <a:off x="0" y="0"/>
-          <a:ext cx="0" cy="0"/>
-          <a:chOff x="0" y="0"/>
-          <a:chExt cx="0" cy="0"/>
-        </a:xfrm>
-      </p:grpSpPr>
-      <p:sp>
-        <p:nvSpPr>
-          <p:cNvPr id="122" name="Google Shape;122;gb0586cafee_0_60:notes"/>
-          <p:cNvSpPr/>
-          <p:nvPr>
-            <p:ph idx="2" type="sldImg"/>
-          </p:nvPr>
-        </p:nvSpPr>
-        <p:spPr>
-          <a:xfrm>
-            <a:off x="381300" y="685800"/>
-            <a:ext cx="6096000" cy="3429000"/>
-          </a:xfrm>
-          <a:custGeom>
-            <a:rect b="b" l="l" r="r" t="t"/>
-            <a:pathLst>
-              <a:path extrusionOk="0" h="120000" w="120000">
-                <a:moveTo>
-                  <a:pt x="0" y="0"/>
-                </a:moveTo>
-                <a:lnTo>
-                  <a:pt x="120000" y="0"/>
-                </a:lnTo>
-                <a:lnTo>
-                  <a:pt x="120000" y="120000"/>
-                </a:lnTo>
-                <a:lnTo>
-                  <a:pt x="0" y="120000"/>
-                </a:lnTo>
-                <a:close/>
-              </a:path>
-            </a:pathLst>
-          </a:custGeom>
-        </p:spPr>
-      </p:sp>
-      <p:sp>
-        <p:nvSpPr>
-          <p:cNvPr id="123" name="Google Shape;123;gb0586cafee_0_60:notes"/>
-          <p:cNvSpPr txBox="1"/>
-          <p:nvPr>
-            <p:ph idx="1" type="body"/>
-          </p:nvPr>
-        </p:nvSpPr>
-        <p:spPr>
-          <a:xfrm>
-            <a:off x="685800" y="4343400"/>
-            <a:ext cx="5486400" cy="4114800"/>
-          </a:xfrm>
-          <a:prstGeom prst="rect">
-            <a:avLst/>
-          </a:prstGeom>
-        </p:spPr>
-        <p:txBody>
-          <a:bodyPr anchorCtr="0" anchor="t" bIns="91425" lIns="91425" spcFirstLastPara="1" rIns="91425" wrap="square" tIns="91425">
-            <a:noAutofit/>
-          </a:bodyPr>
-          <a:lstStyle/>
-          <a:p>
-            <a:pPr indent="0" lvl="0" marL="0" rtl="0" algn="l">
-              <a:spcBef>
-                <a:spcPts val="0"/>
-              </a:spcBef>
-              <a:spcAft>
-                <a:spcPts val="0"/>
-              </a:spcAft>
-              <a:buNone/>
-            </a:pPr>
-            <a:r>
-              <a:t/>
-            </a:r>
-            <a:endParaRPr/>
-          </a:p>
-        </p:txBody>
-      </p:sp>
-    </p:spTree>
-  </p:cSld>
-  <p:clrMapOvr>
-    <a:masterClrMapping/>
-  </p:clrMapOvr>
-</p:notes>
-</file>
-
-<file path=ppt/notesSlides/notesSlide13.xml><?xml version="1.0" encoding="utf-8"?>
-<p:notes xmlns:a="http://schemas.openxmlformats.org/drawingml/2006/main" xmlns:r="http://schemas.openxmlformats.org/officeDocument/2006/relationships" xmlns:mc="http://schemas.openxmlformats.org/markup-compatibility/2006" xmlns:mv="urn:schemas-microsoft-com:mac:vml" xmlns:p="http://schemas.openxmlformats.org/presentationml/2006/main" xmlns:c="http://schemas.openxmlformats.org/drawingml/2006/chart" xmlns:dgm="http://schemas.openxmlformats.org/drawingml/2006/diagram" xmlns:o="urn:schemas-microsoft-com:office:office" xmlns:v="urn:schemas-microsoft-com:vml" xmlns:pvml="urn:schemas-microsoft-com:office:powerpoint" xmlns:com="http://schemas.openxmlformats.org/drawingml/2006/compatibility" xmlns:p14="http://schemas.microsoft.com/office/powerpoint/2010/main" xmlns:p15="http://schemas.microsoft.com/office/powerpoint/2012/main" xmlns:ahyp="http://schemas.microsoft.com/office/drawing/2018/hyperlinkcolor" showMasterPhAnim="0" showMasterSp="0">
-  <p:cSld>
-    <p:spTree>
-      <p:nvGrpSpPr>
-        <p:cNvPr id="127" name="Shape 127"/>
-        <p:cNvGrpSpPr/>
-        <p:nvPr/>
-      </p:nvGrpSpPr>
-      <p:grpSpPr>
-        <a:xfrm>
-          <a:off x="0" y="0"/>
-          <a:ext cx="0" cy="0"/>
-          <a:chOff x="0" y="0"/>
-          <a:chExt cx="0" cy="0"/>
-        </a:xfrm>
-      </p:grpSpPr>
-      <p:sp>
-        <p:nvSpPr>
-          <p:cNvPr id="128" name="Google Shape;128;gb06be9f2b7_0_0:notes"/>
-          <p:cNvSpPr/>
-          <p:nvPr>
-            <p:ph idx="2" type="sldImg"/>
-          </p:nvPr>
-        </p:nvSpPr>
-        <p:spPr>
-          <a:xfrm>
-            <a:off x="381300" y="685800"/>
-            <a:ext cx="6096000" cy="3429000"/>
-          </a:xfrm>
-          <a:custGeom>
-            <a:rect b="b" l="l" r="r" t="t"/>
-            <a:pathLst>
-              <a:path extrusionOk="0" h="120000" w="120000">
-                <a:moveTo>
-                  <a:pt x="0" y="0"/>
-                </a:moveTo>
-                <a:lnTo>
-                  <a:pt x="120000" y="0"/>
-                </a:lnTo>
-                <a:lnTo>
-                  <a:pt x="120000" y="120000"/>
-                </a:lnTo>
-                <a:lnTo>
-                  <a:pt x="0" y="120000"/>
-                </a:lnTo>
-                <a:close/>
-              </a:path>
-            </a:pathLst>
-          </a:custGeom>
-        </p:spPr>
-      </p:sp>
-      <p:sp>
-        <p:nvSpPr>
-          <p:cNvPr id="129" name="Google Shape;129;gb06be9f2b7_0_0:notes"/>
-          <p:cNvSpPr txBox="1"/>
-          <p:nvPr>
-            <p:ph idx="1" type="body"/>
-          </p:nvPr>
-        </p:nvSpPr>
-        <p:spPr>
-          <a:xfrm>
-            <a:off x="685800" y="4343400"/>
-            <a:ext cx="5486400" cy="4114800"/>
-          </a:xfrm>
-          <a:prstGeom prst="rect">
-            <a:avLst/>
-          </a:prstGeom>
-        </p:spPr>
-        <p:txBody>
-          <a:bodyPr anchorCtr="0" anchor="t" bIns="91425" lIns="91425" spcFirstLastPara="1" rIns="91425" wrap="square" tIns="91425">
-            <a:noAutofit/>
-          </a:bodyPr>
-          <a:lstStyle/>
-          <a:p>
-            <a:pPr indent="0" lvl="0" marL="0" rtl="0" algn="l">
-              <a:spcBef>
-                <a:spcPts val="0"/>
-              </a:spcBef>
-              <a:spcAft>
-                <a:spcPts val="0"/>
-              </a:spcAft>
-              <a:buNone/>
-            </a:pPr>
-            <a:r>
-              <a:t/>
-            </a:r>
-            <a:endParaRPr/>
-          </a:p>
-        </p:txBody>
-      </p:sp>
-    </p:spTree>
-  </p:cSld>
-  <p:clrMapOvr>
-    <a:masterClrMapping/>
-  </p:clrMapOvr>
-</p:notes>
-</file>
-
-<file path=ppt/notesSlides/notesSlide2.xml><?xml version="1.0" encoding="utf-8"?>
-<p:notes xmlns:a="http://schemas.openxmlformats.org/drawingml/2006/main" xmlns:r="http://schemas.openxmlformats.org/officeDocument/2006/relationships" xmlns:mc="http://schemas.openxmlformats.org/markup-compatibility/2006" xmlns:mv="urn:schemas-microsoft-com:mac:vml" xmlns:p="http://schemas.openxmlformats.org/presentationml/2006/main" xmlns:c="http://schemas.openxmlformats.org/drawingml/2006/chart" xmlns:dgm="http://schemas.openxmlformats.org/drawingml/2006/diagram" xmlns:o="urn:schemas-microsoft-com:office:office" xmlns:v="urn:schemas-microsoft-com:vml" xmlns:pvml="urn:schemas-microsoft-com:office:powerpoint" xmlns:com="http://schemas.openxmlformats.org/drawingml/2006/compatibility" xmlns:p14="http://schemas.microsoft.com/office/powerpoint/2010/main" xmlns:p15="http://schemas.microsoft.com/office/powerpoint/2012/main" xmlns:ahyp="http://schemas.microsoft.com/office/drawing/2018/hyperlinkcolor" showMasterPhAnim="0" showMasterSp="0">
-  <p:cSld>
-    <p:spTree>
-      <p:nvGrpSpPr>
-        <p:cNvPr id="57" name="Shape 57"/>
-        <p:cNvGrpSpPr/>
-        <p:nvPr/>
-      </p:nvGrpSpPr>
-      <p:grpSpPr>
-        <a:xfrm>
-          <a:off x="0" y="0"/>
-          <a:ext cx="0" cy="0"/>
-          <a:chOff x="0" y="0"/>
-          <a:chExt cx="0" cy="0"/>
-        </a:xfrm>
-      </p:grpSpPr>
-      <p:sp>
-        <p:nvSpPr>
-          <p:cNvPr id="58" name="Google Shape;58;gb0586cafee_0_71:notes"/>
-          <p:cNvSpPr/>
-          <p:nvPr>
-            <p:ph idx="2" type="sldImg"/>
-          </p:nvPr>
-        </p:nvSpPr>
-        <p:spPr>
-          <a:xfrm>
-            <a:off x="381300" y="685800"/>
-            <a:ext cx="6096000" cy="3429000"/>
-          </a:xfrm>
-          <a:custGeom>
-            <a:rect b="b" l="l" r="r" t="t"/>
-            <a:pathLst>
-              <a:path extrusionOk="0" h="120000" w="120000">
-                <a:moveTo>
-                  <a:pt x="0" y="0"/>
-                </a:moveTo>
-                <a:lnTo>
-                  <a:pt x="120000" y="0"/>
-                </a:lnTo>
-                <a:lnTo>
-                  <a:pt x="120000" y="120000"/>
-                </a:lnTo>
-                <a:lnTo>
-                  <a:pt x="0" y="120000"/>
-                </a:lnTo>
-                <a:close/>
-              </a:path>
-            </a:pathLst>
-          </a:custGeom>
-        </p:spPr>
-      </p:sp>
-      <p:sp>
-        <p:nvSpPr>
-          <p:cNvPr id="59" name="Google Shape;59;gb0586cafee_0_71:notes"/>
-          <p:cNvSpPr txBox="1"/>
-          <p:nvPr>
-            <p:ph idx="1" type="body"/>
-          </p:nvPr>
-        </p:nvSpPr>
-        <p:spPr>
-          <a:xfrm>
-            <a:off x="685800" y="4343400"/>
-            <a:ext cx="5486400" cy="4114800"/>
-          </a:xfrm>
-          <a:prstGeom prst="rect">
-            <a:avLst/>
-          </a:prstGeom>
-        </p:spPr>
-        <p:txBody>
-          <a:bodyPr anchorCtr="0" anchor="t" bIns="91425" lIns="91425" spcFirstLastPara="1" rIns="91425" wrap="square" tIns="91425">
-            <a:noAutofit/>
-          </a:bodyPr>
-          <a:lstStyle/>
-          <a:p>
-            <a:pPr indent="0" lvl="0" marL="0" rtl="0" algn="l">
-              <a:spcBef>
-                <a:spcPts val="0"/>
-              </a:spcBef>
-              <a:spcAft>
-                <a:spcPts val="0"/>
-              </a:spcAft>
-              <a:buNone/>
-            </a:pPr>
-            <a:r>
-              <a:t/>
-            </a:r>
-            <a:endParaRPr/>
-          </a:p>
-        </p:txBody>
-      </p:sp>
-    </p:spTree>
-  </p:cSld>
-  <p:clrMapOvr>
-    <a:masterClrMapping/>
-  </p:clrMapOvr>
-</p:notes>
-</file>
-
-<file path=ppt/notesSlides/notesSlide3.xml><?xml version="1.0" encoding="utf-8"?>
-<p:notes xmlns:a="http://schemas.openxmlformats.org/drawingml/2006/main" xmlns:r="http://schemas.openxmlformats.org/officeDocument/2006/relationships" xmlns:mc="http://schemas.openxmlformats.org/markup-compatibility/2006" xmlns:mv="urn:schemas-microsoft-com:mac:vml" xmlns:p="http://schemas.openxmlformats.org/presentationml/2006/main" xmlns:c="http://schemas.openxmlformats.org/drawingml/2006/chart" xmlns:dgm="http://schemas.openxmlformats.org/drawingml/2006/diagram" xmlns:o="urn:schemas-microsoft-com:office:office" xmlns:v="urn:schemas-microsoft-com:vml" xmlns:pvml="urn:schemas-microsoft-com:office:powerpoint" xmlns:com="http://schemas.openxmlformats.org/drawingml/2006/compatibility" xmlns:p14="http://schemas.microsoft.com/office/powerpoint/2010/main" xmlns:p15="http://schemas.microsoft.com/office/powerpoint/2012/main" xmlns:ahyp="http://schemas.microsoft.com/office/drawing/2018/hyperlinkcolor" showMasterPhAnim="0" showMasterSp="0">
-  <p:cSld>
-    <p:spTree>
-      <p:nvGrpSpPr>
-        <p:cNvPr id="63" name="Shape 63"/>
-        <p:cNvGrpSpPr/>
-        <p:nvPr/>
-      </p:nvGrpSpPr>
-      <p:grpSpPr>
-        <a:xfrm>
-          <a:off x="0" y="0"/>
-          <a:ext cx="0" cy="0"/>
-          <a:chOff x="0" y="0"/>
-          <a:chExt cx="0" cy="0"/>
-        </a:xfrm>
-      </p:grpSpPr>
-      <p:sp>
-        <p:nvSpPr>
-          <p:cNvPr id="64" name="Google Shape;64;gb0586cafee_0_0:notes"/>
-          <p:cNvSpPr/>
-          <p:nvPr>
-            <p:ph idx="2" type="sldImg"/>
-          </p:nvPr>
-        </p:nvSpPr>
-        <p:spPr>
-          <a:xfrm>
-            <a:off x="381300" y="685800"/>
-            <a:ext cx="6096000" cy="3429000"/>
-          </a:xfrm>
-          <a:custGeom>
-            <a:rect b="b" l="l" r="r" t="t"/>
-            <a:pathLst>
-              <a:path extrusionOk="0" h="120000" w="120000">
-                <a:moveTo>
-                  <a:pt x="0" y="0"/>
-                </a:moveTo>
-                <a:lnTo>
-                  <a:pt x="120000" y="0"/>
-                </a:lnTo>
-                <a:lnTo>
-                  <a:pt x="120000" y="120000"/>
-                </a:lnTo>
-                <a:lnTo>
-                  <a:pt x="0" y="120000"/>
-                </a:lnTo>
-                <a:close/>
-              </a:path>
-            </a:pathLst>
-          </a:custGeom>
-        </p:spPr>
-      </p:sp>
-      <p:sp>
-        <p:nvSpPr>
-          <p:cNvPr id="65" name="Google Shape;65;gb0586cafee_0_0:notes"/>
-          <p:cNvSpPr txBox="1"/>
-          <p:nvPr>
-            <p:ph idx="1" type="body"/>
-          </p:nvPr>
-        </p:nvSpPr>
-        <p:spPr>
-          <a:xfrm>
-            <a:off x="685800" y="4343400"/>
-            <a:ext cx="5486400" cy="4114800"/>
-          </a:xfrm>
-          <a:prstGeom prst="rect">
-            <a:avLst/>
-          </a:prstGeom>
-        </p:spPr>
-        <p:txBody>
-          <a:bodyPr anchorCtr="0" anchor="t" bIns="91425" lIns="91425" spcFirstLastPara="1" rIns="91425" wrap="square" tIns="91425">
-            <a:noAutofit/>
-          </a:bodyPr>
-          <a:lstStyle/>
-          <a:p>
-            <a:pPr indent="0" lvl="0" marL="0" rtl="0" algn="l">
-              <a:spcBef>
-                <a:spcPts val="0"/>
-              </a:spcBef>
-              <a:spcAft>
-                <a:spcPts val="0"/>
-              </a:spcAft>
-              <a:buNone/>
-            </a:pPr>
-            <a:r>
-              <a:t/>
-            </a:r>
-            <a:endParaRPr/>
-          </a:p>
-        </p:txBody>
-      </p:sp>
-    </p:spTree>
-  </p:cSld>
-  <p:clrMapOvr>
-    <a:masterClrMapping/>
-  </p:clrMapOvr>
-</p:notes>
-</file>
-
-<file path=ppt/notesSlides/notesSlide4.xml><?xml version="1.0" encoding="utf-8"?>
-<p:notes xmlns:a="http://schemas.openxmlformats.org/drawingml/2006/main" xmlns:r="http://schemas.openxmlformats.org/officeDocument/2006/relationships" xmlns:mc="http://schemas.openxmlformats.org/markup-compatibility/2006" xmlns:mv="urn:schemas-microsoft-com:mac:vml" xmlns:p="http://schemas.openxmlformats.org/presentationml/2006/main" xmlns:c="http://schemas.openxmlformats.org/drawingml/2006/chart" xmlns:dgm="http://schemas.openxmlformats.org/drawingml/2006/diagram" xmlns:o="urn:schemas-microsoft-com:office:office" xmlns:v="urn:schemas-microsoft-com:vml" xmlns:pvml="urn:schemas-microsoft-com:office:powerpoint" xmlns:com="http://schemas.openxmlformats.org/drawingml/2006/compatibility" xmlns:p14="http://schemas.microsoft.com/office/powerpoint/2010/main" xmlns:p15="http://schemas.microsoft.com/office/powerpoint/2012/main" xmlns:ahyp="http://schemas.microsoft.com/office/drawing/2018/hyperlinkcolor" showMasterPhAnim="0" showMasterSp="0">
-  <p:cSld>
-    <p:spTree>
-      <p:nvGrpSpPr>
-        <p:cNvPr id="69" name="Shape 69"/>
-        <p:cNvGrpSpPr/>
-        <p:nvPr/>
-      </p:nvGrpSpPr>
-      <p:grpSpPr>
-        <a:xfrm>
-          <a:off x="0" y="0"/>
-          <a:ext cx="0" cy="0"/>
-          <a:chOff x="0" y="0"/>
-          <a:chExt cx="0" cy="0"/>
-        </a:xfrm>
-      </p:grpSpPr>
-      <p:sp>
-        <p:nvSpPr>
-          <p:cNvPr id="70" name="Google Shape;70;gb0586cafee_0_8:notes"/>
-          <p:cNvSpPr/>
-          <p:nvPr>
-            <p:ph idx="2" type="sldImg"/>
-          </p:nvPr>
-        </p:nvSpPr>
-        <p:spPr>
-          <a:xfrm>
-            <a:off x="381300" y="685800"/>
-            <a:ext cx="6096000" cy="3429000"/>
-          </a:xfrm>
-          <a:custGeom>
-            <a:rect b="b" l="l" r="r" t="t"/>
-            <a:pathLst>
-              <a:path extrusionOk="0" h="120000" w="120000">
-                <a:moveTo>
-                  <a:pt x="0" y="0"/>
-                </a:moveTo>
-                <a:lnTo>
-                  <a:pt x="120000" y="0"/>
-                </a:lnTo>
-                <a:lnTo>
-                  <a:pt x="120000" y="120000"/>
-                </a:lnTo>
-                <a:lnTo>
-                  <a:pt x="0" y="120000"/>
-                </a:lnTo>
-                <a:close/>
-              </a:path>
-            </a:pathLst>
-          </a:custGeom>
-        </p:spPr>
-      </p:sp>
-      <p:sp>
-        <p:nvSpPr>
-          <p:cNvPr id="71" name="Google Shape;71;gb0586cafee_0_8:notes"/>
-          <p:cNvSpPr txBox="1"/>
-          <p:nvPr>
-            <p:ph idx="1" type="body"/>
-          </p:nvPr>
-        </p:nvSpPr>
-        <p:spPr>
-          <a:xfrm>
-            <a:off x="685800" y="4343400"/>
-            <a:ext cx="5486400" cy="4114800"/>
-          </a:xfrm>
-          <a:prstGeom prst="rect">
-            <a:avLst/>
-          </a:prstGeom>
-        </p:spPr>
-        <p:txBody>
-          <a:bodyPr anchorCtr="0" anchor="t" bIns="91425" lIns="91425" spcFirstLastPara="1" rIns="91425" wrap="square" tIns="91425">
-            <a:noAutofit/>
-          </a:bodyPr>
-          <a:lstStyle/>
-          <a:p>
-            <a:pPr indent="0" lvl="0" marL="0" rtl="0" algn="l">
-              <a:spcBef>
-                <a:spcPts val="0"/>
-              </a:spcBef>
-              <a:spcAft>
-                <a:spcPts val="0"/>
-              </a:spcAft>
-              <a:buNone/>
-            </a:pPr>
-            <a:r>
-              <a:t/>
-            </a:r>
-            <a:endParaRPr/>
-          </a:p>
-        </p:txBody>
-      </p:sp>
-    </p:spTree>
-  </p:cSld>
-  <p:clrMapOvr>
-    <a:masterClrMapping/>
-  </p:clrMapOvr>
-</p:notes>
-</file>
-
-<file path=ppt/notesSlides/notesSlide5.xml><?xml version="1.0" encoding="utf-8"?>
-<p:notes xmlns:a="http://schemas.openxmlformats.org/drawingml/2006/main" xmlns:r="http://schemas.openxmlformats.org/officeDocument/2006/relationships" xmlns:mc="http://schemas.openxmlformats.org/markup-compatibility/2006" xmlns:mv="urn:schemas-microsoft-com:mac:vml" xmlns:p="http://schemas.openxmlformats.org/presentationml/2006/main" xmlns:c="http://schemas.openxmlformats.org/drawingml/2006/chart" xmlns:dgm="http://schemas.openxmlformats.org/drawingml/2006/diagram" xmlns:o="urn:schemas-microsoft-com:office:office" xmlns:v="urn:schemas-microsoft-com:vml" xmlns:pvml="urn:schemas-microsoft-com:office:powerpoint" xmlns:com="http://schemas.openxmlformats.org/drawingml/2006/compatibility" xmlns:p14="http://schemas.microsoft.com/office/powerpoint/2010/main" xmlns:p15="http://schemas.microsoft.com/office/powerpoint/2012/main" xmlns:ahyp="http://schemas.microsoft.com/office/drawing/2018/hyperlinkcolor" showMasterPhAnim="0" showMasterSp="0">
-  <p:cSld>
-    <p:spTree>
-      <p:nvGrpSpPr>
-        <p:cNvPr id="76" name="Shape 76"/>
-        <p:cNvGrpSpPr/>
-        <p:nvPr/>
-      </p:nvGrpSpPr>
-      <p:grpSpPr>
-        <a:xfrm>
-          <a:off x="0" y="0"/>
-          <a:ext cx="0" cy="0"/>
-          <a:chOff x="0" y="0"/>
-          <a:chExt cx="0" cy="0"/>
-        </a:xfrm>
-      </p:grpSpPr>
-      <p:sp>
-        <p:nvSpPr>
-          <p:cNvPr id="77" name="Google Shape;77;gb0586cafee_0_14:notes"/>
-          <p:cNvSpPr/>
-          <p:nvPr>
-            <p:ph idx="2" type="sldImg"/>
-          </p:nvPr>
-        </p:nvSpPr>
-        <p:spPr>
-          <a:xfrm>
-            <a:off x="381300" y="685800"/>
-            <a:ext cx="6096000" cy="3429000"/>
-          </a:xfrm>
-          <a:custGeom>
-            <a:rect b="b" l="l" r="r" t="t"/>
-            <a:pathLst>
-              <a:path extrusionOk="0" h="120000" w="120000">
-                <a:moveTo>
-                  <a:pt x="0" y="0"/>
-                </a:moveTo>
-                <a:lnTo>
-                  <a:pt x="120000" y="0"/>
-                </a:lnTo>
-                <a:lnTo>
-                  <a:pt x="120000" y="120000"/>
-                </a:lnTo>
-                <a:lnTo>
-                  <a:pt x="0" y="120000"/>
-                </a:lnTo>
-                <a:close/>
-              </a:path>
-            </a:pathLst>
-          </a:custGeom>
-        </p:spPr>
-      </p:sp>
-      <p:sp>
-        <p:nvSpPr>
-          <p:cNvPr id="78" name="Google Shape;78;gb0586cafee_0_14:notes"/>
-          <p:cNvSpPr txBox="1"/>
-          <p:nvPr>
-            <p:ph idx="1" type="body"/>
-          </p:nvPr>
-        </p:nvSpPr>
-        <p:spPr>
-          <a:xfrm>
-            <a:off x="685800" y="4343400"/>
-            <a:ext cx="5486400" cy="4114800"/>
-          </a:xfrm>
-          <a:prstGeom prst="rect">
-            <a:avLst/>
-          </a:prstGeom>
-        </p:spPr>
-        <p:txBody>
-          <a:bodyPr anchorCtr="0" anchor="t" bIns="91425" lIns="91425" spcFirstLastPara="1" rIns="91425" wrap="square" tIns="91425">
-            <a:noAutofit/>
-          </a:bodyPr>
-          <a:lstStyle/>
-          <a:p>
-            <a:pPr indent="0" lvl="0" marL="0" rtl="0" algn="l">
-              <a:spcBef>
-                <a:spcPts val="0"/>
-              </a:spcBef>
-              <a:spcAft>
-                <a:spcPts val="0"/>
-              </a:spcAft>
-              <a:buNone/>
-            </a:pPr>
-            <a:r>
-              <a:t/>
-            </a:r>
-            <a:endParaRPr/>
-          </a:p>
-        </p:txBody>
-      </p:sp>
-    </p:spTree>
-  </p:cSld>
-  <p:clrMapOvr>
-    <a:masterClrMapping/>
-  </p:clrMapOvr>
-</p:notes>
-</file>
-
-<file path=ppt/notesSlides/notesSlide6.xml><?xml version="1.0" encoding="utf-8"?>
-<p:notes xmlns:a="http://schemas.openxmlformats.org/drawingml/2006/main" xmlns:r="http://schemas.openxmlformats.org/officeDocument/2006/relationships" xmlns:mc="http://schemas.openxmlformats.org/markup-compatibility/2006" xmlns:mv="urn:schemas-microsoft-com:mac:vml" xmlns:p="http://schemas.openxmlformats.org/presentationml/2006/main" xmlns:c="http://schemas.openxmlformats.org/drawingml/2006/chart" xmlns:dgm="http://schemas.openxmlformats.org/drawingml/2006/diagram" xmlns:o="urn:schemas-microsoft-com:office:office" xmlns:v="urn:schemas-microsoft-com:vml" xmlns:pvml="urn:schemas-microsoft-com:office:powerpoint" xmlns:com="http://schemas.openxmlformats.org/drawingml/2006/compatibility" xmlns:p14="http://schemas.microsoft.com/office/powerpoint/2010/main" xmlns:p15="http://schemas.microsoft.com/office/powerpoint/2012/main" xmlns:ahyp="http://schemas.microsoft.com/office/drawing/2018/hyperlinkcolor" showMasterPhAnim="0" showMasterSp="0">
-  <p:cSld>
-    <p:spTree>
-      <p:nvGrpSpPr>
-        <p:cNvPr id="83" name="Shape 83"/>
-        <p:cNvGrpSpPr/>
-        <p:nvPr/>
-      </p:nvGrpSpPr>
-      <p:grpSpPr>
-        <a:xfrm>
-          <a:off x="0" y="0"/>
-          <a:ext cx="0" cy="0"/>
-          <a:chOff x="0" y="0"/>
-          <a:chExt cx="0" cy="0"/>
-        </a:xfrm>
-      </p:grpSpPr>
-      <p:sp>
-        <p:nvSpPr>
-          <p:cNvPr id="84" name="Google Shape;84;gb0586cafee_0_22:notes"/>
-          <p:cNvSpPr/>
-          <p:nvPr>
-            <p:ph idx="2" type="sldImg"/>
-          </p:nvPr>
-        </p:nvSpPr>
-        <p:spPr>
-          <a:xfrm>
-            <a:off x="381300" y="685800"/>
-            <a:ext cx="6096000" cy="3429000"/>
-          </a:xfrm>
-          <a:custGeom>
-            <a:rect b="b" l="l" r="r" t="t"/>
-            <a:pathLst>
-              <a:path extrusionOk="0" h="120000" w="120000">
-                <a:moveTo>
-                  <a:pt x="0" y="0"/>
-                </a:moveTo>
-                <a:lnTo>
-                  <a:pt x="120000" y="0"/>
-                </a:lnTo>
-                <a:lnTo>
-                  <a:pt x="120000" y="120000"/>
-                </a:lnTo>
-                <a:lnTo>
-                  <a:pt x="0" y="120000"/>
-                </a:lnTo>
-                <a:close/>
-              </a:path>
-            </a:pathLst>
-          </a:custGeom>
-        </p:spPr>
-      </p:sp>
-      <p:sp>
-        <p:nvSpPr>
-          <p:cNvPr id="85" name="Google Shape;85;gb0586cafee_0_22:notes"/>
-          <p:cNvSpPr txBox="1"/>
-          <p:nvPr>
-            <p:ph idx="1" type="body"/>
-          </p:nvPr>
-        </p:nvSpPr>
-        <p:spPr>
-          <a:xfrm>
-            <a:off x="685800" y="4343400"/>
-            <a:ext cx="5486400" cy="4114800"/>
-          </a:xfrm>
-          <a:prstGeom prst="rect">
-            <a:avLst/>
-          </a:prstGeom>
-        </p:spPr>
-        <p:txBody>
-          <a:bodyPr anchorCtr="0" anchor="t" bIns="91425" lIns="91425" spcFirstLastPara="1" rIns="91425" wrap="square" tIns="91425">
-            <a:noAutofit/>
-          </a:bodyPr>
-          <a:lstStyle/>
-          <a:p>
-            <a:pPr indent="0" lvl="0" marL="0" rtl="0" algn="l">
-              <a:spcBef>
-                <a:spcPts val="0"/>
-              </a:spcBef>
-              <a:spcAft>
-                <a:spcPts val="0"/>
-              </a:spcAft>
-              <a:buNone/>
-            </a:pPr>
-            <a:r>
-              <a:t/>
-            </a:r>
-            <a:endParaRPr/>
-          </a:p>
-        </p:txBody>
-      </p:sp>
-    </p:spTree>
-  </p:cSld>
-  <p:clrMapOvr>
-    <a:masterClrMapping/>
-  </p:clrMapOvr>
-</p:notes>
-</file>
-
-<file path=ppt/notesSlides/notesSlide7.xml><?xml version="1.0" encoding="utf-8"?>
-<p:notes xmlns:a="http://schemas.openxmlformats.org/drawingml/2006/main" xmlns:r="http://schemas.openxmlformats.org/officeDocument/2006/relationships" xmlns:mc="http://schemas.openxmlformats.org/markup-compatibility/2006" xmlns:mv="urn:schemas-microsoft-com:mac:vml" xmlns:p="http://schemas.openxmlformats.org/presentationml/2006/main" xmlns:c="http://schemas.openxmlformats.org/drawingml/2006/chart" xmlns:dgm="http://schemas.openxmlformats.org/drawingml/2006/diagram" xmlns:o="urn:schemas-microsoft-com:office:office" xmlns:v="urn:schemas-microsoft-com:vml" xmlns:pvml="urn:schemas-microsoft-com:office:powerpoint" xmlns:com="http://schemas.openxmlformats.org/drawingml/2006/compatibility" xmlns:p14="http://schemas.microsoft.com/office/powerpoint/2010/main" xmlns:p15="http://schemas.microsoft.com/office/powerpoint/2012/main" xmlns:ahyp="http://schemas.microsoft.com/office/drawing/2018/hyperlinkcolor" showMasterPhAnim="0" showMasterSp="0">
-  <p:cSld>
-    <p:spTree>
-      <p:nvGrpSpPr>
-        <p:cNvPr id="89" name="Shape 89"/>
-        <p:cNvGrpSpPr/>
-        <p:nvPr/>
-      </p:nvGrpSpPr>
-      <p:grpSpPr>
-        <a:xfrm>
-          <a:off x="0" y="0"/>
-          <a:ext cx="0" cy="0"/>
-          <a:chOff x="0" y="0"/>
-          <a:chExt cx="0" cy="0"/>
-        </a:xfrm>
-      </p:grpSpPr>
-      <p:sp>
-        <p:nvSpPr>
-          <p:cNvPr id="90" name="Google Shape;90;gb0586cafee_0_27:notes"/>
-          <p:cNvSpPr/>
-          <p:nvPr>
-            <p:ph idx="2" type="sldImg"/>
-          </p:nvPr>
-        </p:nvSpPr>
-        <p:spPr>
-          <a:xfrm>
-            <a:off x="381300" y="685800"/>
-            <a:ext cx="6096000" cy="3429000"/>
-          </a:xfrm>
-          <a:custGeom>
-            <a:rect b="b" l="l" r="r" t="t"/>
-            <a:pathLst>
-              <a:path extrusionOk="0" h="120000" w="120000">
-                <a:moveTo>
-                  <a:pt x="0" y="0"/>
-                </a:moveTo>
-                <a:lnTo>
-                  <a:pt x="120000" y="0"/>
-                </a:lnTo>
-                <a:lnTo>
-                  <a:pt x="120000" y="120000"/>
-                </a:lnTo>
-                <a:lnTo>
-                  <a:pt x="0" y="120000"/>
-                </a:lnTo>
-                <a:close/>
-              </a:path>
-            </a:pathLst>
-          </a:custGeom>
-        </p:spPr>
-      </p:sp>
-      <p:sp>
-        <p:nvSpPr>
-          <p:cNvPr id="91" name="Google Shape;91;gb0586cafee_0_27:notes"/>
-          <p:cNvSpPr txBox="1"/>
-          <p:nvPr>
-            <p:ph idx="1" type="body"/>
-          </p:nvPr>
-        </p:nvSpPr>
-        <p:spPr>
-          <a:xfrm>
-            <a:off x="685800" y="4343400"/>
-            <a:ext cx="5486400" cy="4114800"/>
-          </a:xfrm>
-          <a:prstGeom prst="rect">
-            <a:avLst/>
-          </a:prstGeom>
-        </p:spPr>
-        <p:txBody>
-          <a:bodyPr anchorCtr="0" anchor="t" bIns="91425" lIns="91425" spcFirstLastPara="1" rIns="91425" wrap="square" tIns="91425">
-            <a:noAutofit/>
-          </a:bodyPr>
-          <a:lstStyle/>
-          <a:p>
-            <a:pPr indent="0" lvl="0" marL="0" rtl="0" algn="l">
-              <a:spcBef>
-                <a:spcPts val="0"/>
-              </a:spcBef>
-              <a:spcAft>
-                <a:spcPts val="0"/>
-              </a:spcAft>
-              <a:buNone/>
-            </a:pPr>
-            <a:r>
-              <a:t/>
-            </a:r>
-            <a:endParaRPr/>
-          </a:p>
-        </p:txBody>
-      </p:sp>
-    </p:spTree>
-  </p:cSld>
-  <p:clrMapOvr>
-    <a:masterClrMapping/>
-  </p:clrMapOvr>
-</p:notes>
-</file>
-
-<file path=ppt/notesSlides/notesSlide8.xml><?xml version="1.0" encoding="utf-8"?>
-<p:notes xmlns:a="http://schemas.openxmlformats.org/drawingml/2006/main" xmlns:r="http://schemas.openxmlformats.org/officeDocument/2006/relationships" xmlns:mc="http://schemas.openxmlformats.org/markup-compatibility/2006" xmlns:mv="urn:schemas-microsoft-com:mac:vml" xmlns:p="http://schemas.openxmlformats.org/presentationml/2006/main" xmlns:c="http://schemas.openxmlformats.org/drawingml/2006/chart" xmlns:dgm="http://schemas.openxmlformats.org/drawingml/2006/diagram" xmlns:o="urn:schemas-microsoft-com:office:office" xmlns:v="urn:schemas-microsoft-com:vml" xmlns:pvml="urn:schemas-microsoft-com:office:powerpoint" xmlns:com="http://schemas.openxmlformats.org/drawingml/2006/compatibility" xmlns:p14="http://schemas.microsoft.com/office/powerpoint/2010/main" xmlns:p15="http://schemas.microsoft.com/office/powerpoint/2012/main" xmlns:ahyp="http://schemas.microsoft.com/office/drawing/2018/hyperlinkcolor" showMasterPhAnim="0" showMasterSp="0">
-  <p:cSld>
-    <p:spTree>
-      <p:nvGrpSpPr>
-        <p:cNvPr id="95" name="Shape 95"/>
-        <p:cNvGrpSpPr/>
-        <p:nvPr/>
-      </p:nvGrpSpPr>
-      <p:grpSpPr>
-        <a:xfrm>
-          <a:off x="0" y="0"/>
-          <a:ext cx="0" cy="0"/>
-          <a:chOff x="0" y="0"/>
-          <a:chExt cx="0" cy="0"/>
-        </a:xfrm>
-      </p:grpSpPr>
-      <p:sp>
-        <p:nvSpPr>
-          <p:cNvPr id="96" name="Google Shape;96;gb0586cafee_0_32:notes"/>
-          <p:cNvSpPr/>
-          <p:nvPr>
-            <p:ph idx="2" type="sldImg"/>
-          </p:nvPr>
-        </p:nvSpPr>
-        <p:spPr>
-          <a:xfrm>
-            <a:off x="381300" y="685800"/>
-            <a:ext cx="6096000" cy="3429000"/>
-          </a:xfrm>
-          <a:custGeom>
-            <a:rect b="b" l="l" r="r" t="t"/>
-            <a:pathLst>
-              <a:path extrusionOk="0" h="120000" w="120000">
-                <a:moveTo>
-                  <a:pt x="0" y="0"/>
-                </a:moveTo>
-                <a:lnTo>
-                  <a:pt x="120000" y="0"/>
-                </a:lnTo>
-                <a:lnTo>
-                  <a:pt x="120000" y="120000"/>
-                </a:lnTo>
-                <a:lnTo>
-                  <a:pt x="0" y="120000"/>
-                </a:lnTo>
-                <a:close/>
-              </a:path>
-            </a:pathLst>
-          </a:custGeom>
-        </p:spPr>
-      </p:sp>
-      <p:sp>
-        <p:nvSpPr>
-          <p:cNvPr id="97" name="Google Shape;97;gb0586cafee_0_32:notes"/>
-          <p:cNvSpPr txBox="1"/>
-          <p:nvPr>
-            <p:ph idx="1" type="body"/>
-          </p:nvPr>
-        </p:nvSpPr>
-        <p:spPr>
-          <a:xfrm>
-            <a:off x="685800" y="4343400"/>
-            <a:ext cx="5486400" cy="4114800"/>
-          </a:xfrm>
-          <a:prstGeom prst="rect">
-            <a:avLst/>
-          </a:prstGeom>
-        </p:spPr>
-        <p:txBody>
-          <a:bodyPr anchorCtr="0" anchor="t" bIns="91425" lIns="91425" spcFirstLastPara="1" rIns="91425" wrap="square" tIns="91425">
-            <a:noAutofit/>
-          </a:bodyPr>
-          <a:lstStyle/>
-          <a:p>
-            <a:pPr indent="0" lvl="0" marL="0" rtl="0" algn="l">
-              <a:spcBef>
-                <a:spcPts val="0"/>
-              </a:spcBef>
-              <a:spcAft>
-                <a:spcPts val="0"/>
-              </a:spcAft>
-              <a:buNone/>
-            </a:pPr>
-            <a:r>
-              <a:t/>
-            </a:r>
-            <a:endParaRPr/>
-          </a:p>
-        </p:txBody>
-      </p:sp>
-    </p:spTree>
-  </p:cSld>
-  <p:clrMapOvr>
-    <a:masterClrMapping/>
-  </p:clrMapOvr>
-</p:notes>
-</file>
-
-<file path=ppt/notesSlides/notesSlide9.xml><?xml version="1.0" encoding="utf-8"?>
-<p:notes xmlns:a="http://schemas.openxmlformats.org/drawingml/2006/main" xmlns:r="http://schemas.openxmlformats.org/officeDocument/2006/relationships" xmlns:mc="http://schemas.openxmlformats.org/markup-compatibility/2006" xmlns:mv="urn:schemas-microsoft-com:mac:vml" xmlns:p="http://schemas.openxmlformats.org/presentationml/2006/main" xmlns:c="http://schemas.openxmlformats.org/drawingml/2006/chart" xmlns:dgm="http://schemas.openxmlformats.org/drawingml/2006/diagram" xmlns:o="urn:schemas-microsoft-com:office:office" xmlns:v="urn:schemas-microsoft-com:vml" xmlns:pvml="urn:schemas-microsoft-com:office:powerpoint" xmlns:com="http://schemas.openxmlformats.org/drawingml/2006/compatibility" xmlns:p14="http://schemas.microsoft.com/office/powerpoint/2010/main" xmlns:p15="http://schemas.microsoft.com/office/powerpoint/2012/main" xmlns:ahyp="http://schemas.microsoft.com/office/drawing/2018/hyperlinkcolor" showMasterPhAnim="0" showMasterSp="0">
-  <p:cSld>
-    <p:spTree>
-      <p:nvGrpSpPr>
-        <p:cNvPr id="102" name="Shape 102"/>
-        <p:cNvGrpSpPr/>
-        <p:nvPr/>
-      </p:nvGrpSpPr>
-      <p:grpSpPr>
-        <a:xfrm>
-          <a:off x="0" y="0"/>
-          <a:ext cx="0" cy="0"/>
-          <a:chOff x="0" y="0"/>
-          <a:chExt cx="0" cy="0"/>
-        </a:xfrm>
-      </p:grpSpPr>
-      <p:sp>
-        <p:nvSpPr>
-          <p:cNvPr id="103" name="Google Shape;103;gb0586cafee_0_41:notes"/>
-          <p:cNvSpPr/>
-          <p:nvPr>
-            <p:ph idx="2" type="sldImg"/>
-          </p:nvPr>
-        </p:nvSpPr>
-        <p:spPr>
-          <a:xfrm>
-            <a:off x="381300" y="685800"/>
-            <a:ext cx="6096000" cy="3429000"/>
-          </a:xfrm>
-          <a:custGeom>
-            <a:rect b="b" l="l" r="r" t="t"/>
-            <a:pathLst>
-              <a:path extrusionOk="0" h="120000" w="120000">
-                <a:moveTo>
-                  <a:pt x="0" y="0"/>
-                </a:moveTo>
-                <a:lnTo>
-                  <a:pt x="120000" y="0"/>
-                </a:lnTo>
-                <a:lnTo>
-                  <a:pt x="120000" y="120000"/>
-                </a:lnTo>
-                <a:lnTo>
-                  <a:pt x="0" y="120000"/>
-                </a:lnTo>
-                <a:close/>
-              </a:path>
-            </a:pathLst>
-          </a:custGeom>
-        </p:spPr>
-      </p:sp>
-      <p:sp>
-        <p:nvSpPr>
-          <p:cNvPr id="104" name="Google Shape;104;gb0586cafee_0_41:notes"/>
-          <p:cNvSpPr txBox="1"/>
-          <p:nvPr>
-            <p:ph idx="1" type="body"/>
-          </p:nvPr>
-        </p:nvSpPr>
-        <p:spPr>
-          <a:xfrm>
-            <a:off x="685800" y="4343400"/>
-            <a:ext cx="5486400" cy="4114800"/>
-          </a:xfrm>
-          <a:prstGeom prst="rect">
-            <a:avLst/>
-          </a:prstGeom>
-        </p:spPr>
-        <p:txBody>
-          <a:bodyPr anchorCtr="0" anchor="t" bIns="91425" lIns="91425" spcFirstLastPara="1" rIns="91425" wrap="square" tIns="91425">
-            <a:noAutofit/>
-          </a:bodyPr>
-          <a:lstStyle/>
-          <a:p>
-            <a:pPr indent="0" lvl="0" marL="0" rtl="0" algn="l">
-              <a:spcBef>
-                <a:spcPts val="0"/>
-              </a:spcBef>
-              <a:spcAft>
-                <a:spcPts val="0"/>
-              </a:spcAft>
-              <a:buNone/>
-            </a:pPr>
-            <a:r>
-              <a:t/>
-            </a:r>
-            <a:endParaRPr/>
-          </a:p>
-        </p:txBody>
-      </p:sp>
-    </p:spTree>
-  </p:cSld>
-  <p:clrMapOvr>
-    <a:masterClrMapping/>
-  </p:clrMapOvr>
-</p:notes>
-</file>
-
-<file path=ppt/slideLayouts/slideLayout1.xml><?xml version="1.0" encoding="utf-8"?>
+<file path=ppt\slideLayouts\slideLayout1.xml><?xml version="1.0" encoding="utf-8"?>
 <p:sldLayout xmlns:a="http://schemas.openxmlformats.org/drawingml/2006/main" xmlns:r="http://schemas.openxmlformats.org/officeDocument/2006/relationships" xmlns:mc="http://schemas.openxmlformats.org/markup-compatibility/2006" xmlns:mv="urn:schemas-microsoft-com:mac:vml" xmlns:p="http://schemas.openxmlformats.org/presentationml/2006/main" xmlns:c="http://schemas.openxmlformats.org/drawingml/2006/chart" xmlns:dgm="http://schemas.openxmlformats.org/drawingml/2006/diagram" xmlns:o="urn:schemas-microsoft-com:office:office" xmlns:v="urn:schemas-microsoft-com:vml" xmlns:pvml="urn:schemas-microsoft-com:office:powerpoint" xmlns:com="http://schemas.openxmlformats.org/drawingml/2006/compatibility" xmlns:p14="http://schemas.microsoft.com/office/powerpoint/2010/main" xmlns:p15="http://schemas.microsoft.com/office/powerpoint/2012/main" xmlns:ahyp="http://schemas.microsoft.com/office/drawing/2018/hyperlinkcolor" matchingName="Title slide" type="title">
   <p:cSld name="TITLE">
     <p:spTree>
@@ -2364,7 +2368,7 @@
 </p:sldLayout>
 </file>
 
-<file path=ppt/slideLayouts/slideLayout10.xml><?xml version="1.0" encoding="utf-8"?>
+<file path=ppt\slideLayouts\slideLayout10.xml><?xml version="1.0" encoding="utf-8"?>
 <p:sldLayout xmlns:a="http://schemas.openxmlformats.org/drawingml/2006/main" xmlns:r="http://schemas.openxmlformats.org/officeDocument/2006/relationships" xmlns:mc="http://schemas.openxmlformats.org/markup-compatibility/2006" xmlns:mv="urn:schemas-microsoft-com:mac:vml" xmlns:p="http://schemas.openxmlformats.org/presentationml/2006/main" xmlns:c="http://schemas.openxmlformats.org/drawingml/2006/chart" xmlns:dgm="http://schemas.openxmlformats.org/drawingml/2006/diagram" xmlns:o="urn:schemas-microsoft-com:office:office" xmlns:v="urn:schemas-microsoft-com:vml" xmlns:pvml="urn:schemas-microsoft-com:office:powerpoint" xmlns:com="http://schemas.openxmlformats.org/drawingml/2006/compatibility" xmlns:p14="http://schemas.microsoft.com/office/powerpoint/2010/main" xmlns:p15="http://schemas.microsoft.com/office/powerpoint/2012/main" xmlns:ahyp="http://schemas.microsoft.com/office/drawing/2018/hyperlinkcolor" matchingName="Big number">
   <p:cSld name="BIG_NUMBER">
     <p:spTree>
@@ -2720,7 +2724,7 @@
 </p:sldLayout>
 </file>
 
-<file path=ppt/slideLayouts/slideLayout11.xml><?xml version="1.0" encoding="utf-8"?>
+<file path=ppt\slideLayouts\slideLayout11.xml><?xml version="1.0" encoding="utf-8"?>
 <p:sldLayout xmlns:a="http://schemas.openxmlformats.org/drawingml/2006/main" xmlns:r="http://schemas.openxmlformats.org/officeDocument/2006/relationships" xmlns:mc="http://schemas.openxmlformats.org/markup-compatibility/2006" xmlns:mv="urn:schemas-microsoft-com:mac:vml" xmlns:p="http://schemas.openxmlformats.org/presentationml/2006/main" xmlns:c="http://schemas.openxmlformats.org/drawingml/2006/chart" xmlns:dgm="http://schemas.openxmlformats.org/drawingml/2006/diagram" xmlns:o="urn:schemas-microsoft-com:office:office" xmlns:v="urn:schemas-microsoft-com:vml" xmlns:pvml="urn:schemas-microsoft-com:office:powerpoint" xmlns:com="http://schemas.openxmlformats.org/drawingml/2006/compatibility" xmlns:p14="http://schemas.microsoft.com/office/powerpoint/2010/main" xmlns:p15="http://schemas.microsoft.com/office/powerpoint/2012/main" xmlns:ahyp="http://schemas.microsoft.com/office/drawing/2018/hyperlinkcolor" matchingName="Blank" type="blank">
   <p:cSld name="BLANK">
     <p:spTree>
@@ -2822,7 +2826,7 @@
 </p:sldLayout>
 </file>
 
-<file path=ppt/slideLayouts/slideLayout2.xml><?xml version="1.0" encoding="utf-8"?>
+<file path=ppt\slideLayouts\slideLayout2.xml><?xml version="1.0" encoding="utf-8"?>
 <p:sldLayout xmlns:a="http://schemas.openxmlformats.org/drawingml/2006/main" xmlns:r="http://schemas.openxmlformats.org/officeDocument/2006/relationships" xmlns:mc="http://schemas.openxmlformats.org/markup-compatibility/2006" xmlns:mv="urn:schemas-microsoft-com:mac:vml" xmlns:p="http://schemas.openxmlformats.org/presentationml/2006/main" xmlns:c="http://schemas.openxmlformats.org/drawingml/2006/chart" xmlns:dgm="http://schemas.openxmlformats.org/drawingml/2006/diagram" xmlns:o="urn:schemas-microsoft-com:office:office" xmlns:v="urn:schemas-microsoft-com:vml" xmlns:pvml="urn:schemas-microsoft-com:office:powerpoint" xmlns:com="http://schemas.openxmlformats.org/drawingml/2006/compatibility" xmlns:p14="http://schemas.microsoft.com/office/powerpoint/2010/main" xmlns:p15="http://schemas.microsoft.com/office/powerpoint/2012/main" xmlns:ahyp="http://schemas.microsoft.com/office/drawing/2018/hyperlinkcolor" matchingName="Section header" type="secHead">
   <p:cSld name="SECTION_HEADER">
     <p:spTree>
@@ -3049,7 +3053,7 @@
 </p:sldLayout>
 </file>
 
-<file path=ppt/slideLayouts/slideLayout3.xml><?xml version="1.0" encoding="utf-8"?>
+<file path=ppt\slideLayouts\slideLayout3.xml><?xml version="1.0" encoding="utf-8"?>
 <p:sldLayout xmlns:a="http://schemas.openxmlformats.org/drawingml/2006/main" xmlns:r="http://schemas.openxmlformats.org/officeDocument/2006/relationships" xmlns:mc="http://schemas.openxmlformats.org/markup-compatibility/2006" xmlns:mv="urn:schemas-microsoft-com:mac:vml" xmlns:p="http://schemas.openxmlformats.org/presentationml/2006/main" xmlns:c="http://schemas.openxmlformats.org/drawingml/2006/chart" xmlns:dgm="http://schemas.openxmlformats.org/drawingml/2006/diagram" xmlns:o="urn:schemas-microsoft-com:office:office" xmlns:v="urn:schemas-microsoft-com:vml" xmlns:pvml="urn:schemas-microsoft-com:office:powerpoint" xmlns:com="http://schemas.openxmlformats.org/drawingml/2006/compatibility" xmlns:p14="http://schemas.microsoft.com/office/powerpoint/2010/main" xmlns:p15="http://schemas.microsoft.com/office/powerpoint/2012/main" xmlns:ahyp="http://schemas.microsoft.com/office/drawing/2018/hyperlinkcolor" matchingName="Title and body" type="tx">
   <p:cSld name="TITLE_AND_BODY">
     <p:spTree>
@@ -3401,7 +3405,7 @@
 </p:sldLayout>
 </file>
 
-<file path=ppt/slideLayouts/slideLayout4.xml><?xml version="1.0" encoding="utf-8"?>
+<file path=ppt\slideLayouts\slideLayout4.xml><?xml version="1.0" encoding="utf-8"?>
 <p:sldLayout xmlns:a="http://schemas.openxmlformats.org/drawingml/2006/main" xmlns:r="http://schemas.openxmlformats.org/officeDocument/2006/relationships" xmlns:mc="http://schemas.openxmlformats.org/markup-compatibility/2006" xmlns:mv="urn:schemas-microsoft-com:mac:vml" xmlns:p="http://schemas.openxmlformats.org/presentationml/2006/main" xmlns:c="http://schemas.openxmlformats.org/drawingml/2006/chart" xmlns:dgm="http://schemas.openxmlformats.org/drawingml/2006/diagram" xmlns:o="urn:schemas-microsoft-com:office:office" xmlns:v="urn:schemas-microsoft-com:vml" xmlns:pvml="urn:schemas-microsoft-com:office:powerpoint" xmlns:com="http://schemas.openxmlformats.org/drawingml/2006/compatibility" xmlns:p14="http://schemas.microsoft.com/office/powerpoint/2010/main" xmlns:p15="http://schemas.microsoft.com/office/powerpoint/2012/main" xmlns:ahyp="http://schemas.microsoft.com/office/drawing/2018/hyperlinkcolor" matchingName="Title and two columns" type="twoColTx">
   <p:cSld name="TITLE_AND_TWO_COLUMNS">
     <p:spTree>
@@ -3878,7 +3882,7 @@
 </p:sldLayout>
 </file>
 
-<file path=ppt/slideLayouts/slideLayout5.xml><?xml version="1.0" encoding="utf-8"?>
+<file path=ppt\slideLayouts\slideLayout5.xml><?xml version="1.0" encoding="utf-8"?>
 <p:sldLayout xmlns:a="http://schemas.openxmlformats.org/drawingml/2006/main" xmlns:r="http://schemas.openxmlformats.org/officeDocument/2006/relationships" xmlns:mc="http://schemas.openxmlformats.org/markup-compatibility/2006" xmlns:mv="urn:schemas-microsoft-com:mac:vml" xmlns:p="http://schemas.openxmlformats.org/presentationml/2006/main" xmlns:c="http://schemas.openxmlformats.org/drawingml/2006/chart" xmlns:dgm="http://schemas.openxmlformats.org/drawingml/2006/diagram" xmlns:o="urn:schemas-microsoft-com:office:office" xmlns:v="urn:schemas-microsoft-com:vml" xmlns:pvml="urn:schemas-microsoft-com:office:powerpoint" xmlns:com="http://schemas.openxmlformats.org/drawingml/2006/compatibility" xmlns:p14="http://schemas.microsoft.com/office/powerpoint/2010/main" xmlns:p15="http://schemas.microsoft.com/office/powerpoint/2012/main" xmlns:ahyp="http://schemas.microsoft.com/office/drawing/2018/hyperlinkcolor" matchingName="Title only" type="titleOnly">
   <p:cSld name="TITLE_ONLY">
     <p:spTree>
@@ -4105,7 +4109,7 @@
 </p:sldLayout>
 </file>
 
-<file path=ppt/slideLayouts/slideLayout6.xml><?xml version="1.0" encoding="utf-8"?>
+<file path=ppt\slideLayouts\slideLayout6.xml><?xml version="1.0" encoding="utf-8"?>
 <p:sldLayout xmlns:a="http://schemas.openxmlformats.org/drawingml/2006/main" xmlns:r="http://schemas.openxmlformats.org/officeDocument/2006/relationships" xmlns:mc="http://schemas.openxmlformats.org/markup-compatibility/2006" xmlns:mv="urn:schemas-microsoft-com:mac:vml" xmlns:p="http://schemas.openxmlformats.org/presentationml/2006/main" xmlns:c="http://schemas.openxmlformats.org/drawingml/2006/chart" xmlns:dgm="http://schemas.openxmlformats.org/drawingml/2006/diagram" xmlns:o="urn:schemas-microsoft-com:office:office" xmlns:v="urn:schemas-microsoft-com:vml" xmlns:pvml="urn:schemas-microsoft-com:office:powerpoint" xmlns:com="http://schemas.openxmlformats.org/drawingml/2006/compatibility" xmlns:p14="http://schemas.microsoft.com/office/powerpoint/2010/main" xmlns:p15="http://schemas.microsoft.com/office/powerpoint/2012/main" xmlns:ahyp="http://schemas.microsoft.com/office/drawing/2018/hyperlinkcolor" matchingName="One column text">
   <p:cSld name="ONE_COLUMN_TEXT">
     <p:spTree>
@@ -4457,7 +4461,7 @@
 </p:sldLayout>
 </file>
 
-<file path=ppt/slideLayouts/slideLayout7.xml><?xml version="1.0" encoding="utf-8"?>
+<file path=ppt\slideLayouts\slideLayout7.xml><?xml version="1.0" encoding="utf-8"?>
 <p:sldLayout xmlns:a="http://schemas.openxmlformats.org/drawingml/2006/main" xmlns:r="http://schemas.openxmlformats.org/officeDocument/2006/relationships" xmlns:mc="http://schemas.openxmlformats.org/markup-compatibility/2006" xmlns:mv="urn:schemas-microsoft-com:mac:vml" xmlns:p="http://schemas.openxmlformats.org/presentationml/2006/main" xmlns:c="http://schemas.openxmlformats.org/drawingml/2006/chart" xmlns:dgm="http://schemas.openxmlformats.org/drawingml/2006/diagram" xmlns:o="urn:schemas-microsoft-com:office:office" xmlns:v="urn:schemas-microsoft-com:vml" xmlns:pvml="urn:schemas-microsoft-com:office:powerpoint" xmlns:com="http://schemas.openxmlformats.org/drawingml/2006/compatibility" xmlns:p14="http://schemas.microsoft.com/office/powerpoint/2010/main" xmlns:p15="http://schemas.microsoft.com/office/powerpoint/2012/main" xmlns:ahyp="http://schemas.microsoft.com/office/drawing/2018/hyperlinkcolor" matchingName="Main point">
   <p:cSld name="MAIN_POINT">
     <p:spTree>
@@ -4684,7 +4688,7 @@
 </p:sldLayout>
 </file>
 
-<file path=ppt/slideLayouts/slideLayout8.xml><?xml version="1.0" encoding="utf-8"?>
+<file path=ppt\slideLayouts\slideLayout8.xml><?xml version="1.0" encoding="utf-8"?>
 <p:sldLayout xmlns:a="http://schemas.openxmlformats.org/drawingml/2006/main" xmlns:r="http://schemas.openxmlformats.org/officeDocument/2006/relationships" xmlns:mc="http://schemas.openxmlformats.org/markup-compatibility/2006" xmlns:mv="urn:schemas-microsoft-com:mac:vml" xmlns:p="http://schemas.openxmlformats.org/presentationml/2006/main" xmlns:c="http://schemas.openxmlformats.org/drawingml/2006/chart" xmlns:dgm="http://schemas.openxmlformats.org/drawingml/2006/diagram" xmlns:o="urn:schemas-microsoft-com:office:office" xmlns:v="urn:schemas-microsoft-com:vml" xmlns:pvml="urn:schemas-microsoft-com:office:powerpoint" xmlns:com="http://schemas.openxmlformats.org/drawingml/2006/compatibility" xmlns:p14="http://schemas.microsoft.com/office/powerpoint/2010/main" xmlns:p15="http://schemas.microsoft.com/office/powerpoint/2012/main" xmlns:ahyp="http://schemas.microsoft.com/office/drawing/2018/hyperlinkcolor" matchingName="Section title and description">
   <p:cSld name="SECTION_TITLE_AND_DESCRIPTION">
     <p:spTree>
@@ -5231,7 +5235,7 @@
 </p:sldLayout>
 </file>
 
-<file path=ppt/slideLayouts/slideLayout9.xml><?xml version="1.0" encoding="utf-8"?>
+<file path=ppt\slideLayouts\slideLayout9.xml><?xml version="1.0" encoding="utf-8"?>
 <p:sldLayout xmlns:a="http://schemas.openxmlformats.org/drawingml/2006/main" xmlns:r="http://schemas.openxmlformats.org/officeDocument/2006/relationships" xmlns:mc="http://schemas.openxmlformats.org/markup-compatibility/2006" xmlns:mv="urn:schemas-microsoft-com:mac:vml" xmlns:p="http://schemas.openxmlformats.org/presentationml/2006/main" xmlns:c="http://schemas.openxmlformats.org/drawingml/2006/chart" xmlns:dgm="http://schemas.openxmlformats.org/drawingml/2006/diagram" xmlns:o="urn:schemas-microsoft-com:office:office" xmlns:v="urn:schemas-microsoft-com:vml" xmlns:pvml="urn:schemas-microsoft-com:office:powerpoint" xmlns:com="http://schemas.openxmlformats.org/drawingml/2006/compatibility" xmlns:p14="http://schemas.microsoft.com/office/powerpoint/2010/main" xmlns:p15="http://schemas.microsoft.com/office/powerpoint/2012/main" xmlns:ahyp="http://schemas.microsoft.com/office/drawing/2018/hyperlinkcolor" matchingName="Caption">
   <p:cSld name="CAPTION_ONLY">
     <p:spTree>
@@ -5373,7 +5377,7 @@
 </p:sldLayout>
 </file>
 
-<file path=ppt/slideMasters/slideMaster1.xml><?xml version="1.0" encoding="utf-8"?>
+<file path=ppt\slideMasters\slideMaster1.xml><?xml version="1.0" encoding="utf-8"?>
 <p:sldMaster xmlns:a="http://schemas.openxmlformats.org/drawingml/2006/main" xmlns:r="http://schemas.openxmlformats.org/officeDocument/2006/relationships" xmlns:mc="http://schemas.openxmlformats.org/markup-compatibility/2006" xmlns:mv="urn:schemas-microsoft-com:mac:vml" xmlns:p="http://schemas.openxmlformats.org/presentationml/2006/main" xmlns:c="http://schemas.openxmlformats.org/drawingml/2006/chart" xmlns:dgm="http://schemas.openxmlformats.org/drawingml/2006/diagram" xmlns:o="urn:schemas-microsoft-com:office:office" xmlns:v="urn:schemas-microsoft-com:vml" xmlns:pvml="urn:schemas-microsoft-com:office:powerpoint" xmlns:com="http://schemas.openxmlformats.org/drawingml/2006/compatibility" xmlns:p14="http://schemas.microsoft.com/office/powerpoint/2010/main" xmlns:p15="http://schemas.microsoft.com/office/powerpoint/2012/main" xmlns:ahyp="http://schemas.microsoft.com/office/drawing/2018/hyperlinkcolor">
   <p:cSld name="simple-light-2">
     <p:bg>
@@ -6634,7 +6638,7 @@
 </p:sldMaster>
 </file>
 
-<file path=ppt/slides/slide1.xml><?xml version="1.0" encoding="utf-8"?>
+<file path=ppt\slides\slide1.xml><?xml version="1.0" encoding="utf-8"?>
 <p:sld xmlns:a="http://schemas.openxmlformats.org/drawingml/2006/main" xmlns:r="http://schemas.openxmlformats.org/officeDocument/2006/relationships" xmlns:mc="http://schemas.openxmlformats.org/markup-compatibility/2006" xmlns:mv="urn:schemas-microsoft-com:mac:vml" xmlns:p="http://schemas.openxmlformats.org/presentationml/2006/main" xmlns:c="http://schemas.openxmlformats.org/drawingml/2006/chart" xmlns:dgm="http://schemas.openxmlformats.org/drawingml/2006/diagram" xmlns:o="urn:schemas-microsoft-com:office:office" xmlns:v="urn:schemas-microsoft-com:vml" xmlns:pvml="urn:schemas-microsoft-com:office:powerpoint" xmlns:com="http://schemas.openxmlformats.org/drawingml/2006/compatibility" xmlns:p14="http://schemas.microsoft.com/office/powerpoint/2010/main" xmlns:p15="http://schemas.microsoft.com/office/powerpoint/2012/main" xmlns:ahyp="http://schemas.microsoft.com/office/drawing/2018/hyperlinkcolor">
   <p:cSld>
     <p:spTree>
@@ -6725,7 +6729,7 @@
             </a:pPr>
             <a:r>
               <a:rPr lang="en-GB"/>
-              <a:t>  Shivam Vatshayan</a:t>
+              <a:t>  Shivam toshi</a:t>
             </a:r>
             <a:endParaRPr/>
           </a:p>
@@ -6782,7 +6786,7 @@
 </p:sld>
 </file>
 
-<file path=ppt/slides/slide10.xml><?xml version="1.0" encoding="utf-8"?>
+<file path=ppt\slides\slide10.xml><?xml version="1.0" encoding="utf-8"?>
 <p:sld xmlns:a="http://schemas.openxmlformats.org/drawingml/2006/main" xmlns:r="http://schemas.openxmlformats.org/officeDocument/2006/relationships" xmlns:mc="http://schemas.openxmlformats.org/markup-compatibility/2006" xmlns:mv="urn:schemas-microsoft-com:mac:vml" xmlns:p="http://schemas.openxmlformats.org/presentationml/2006/main" xmlns:c="http://schemas.openxmlformats.org/drawingml/2006/chart" xmlns:dgm="http://schemas.openxmlformats.org/drawingml/2006/diagram" xmlns:o="urn:schemas-microsoft-com:office:office" xmlns:v="urn:schemas-microsoft-com:vml" xmlns:pvml="urn:schemas-microsoft-com:office:powerpoint" xmlns:com="http://schemas.openxmlformats.org/drawingml/2006/compatibility" xmlns:p14="http://schemas.microsoft.com/office/powerpoint/2010/main" xmlns:p15="http://schemas.microsoft.com/office/powerpoint/2012/main" xmlns:ahyp="http://schemas.microsoft.com/office/drawing/2018/hyperlinkcolor">
   <p:cSld>
     <p:spTree>
@@ -6914,7 +6918,7 @@
 </p:sld>
 </file>
 
-<file path=ppt/slides/slide11.xml><?xml version="1.0" encoding="utf-8"?>
+<file path=ppt\slides\slide11.xml><?xml version="1.0" encoding="utf-8"?>
 <p:sld xmlns:a="http://schemas.openxmlformats.org/drawingml/2006/main" xmlns:r="http://schemas.openxmlformats.org/officeDocument/2006/relationships" xmlns:mc="http://schemas.openxmlformats.org/markup-compatibility/2006" xmlns:mv="urn:schemas-microsoft-com:mac:vml" xmlns:p="http://schemas.openxmlformats.org/presentationml/2006/main" xmlns:c="http://schemas.openxmlformats.org/drawingml/2006/chart" xmlns:dgm="http://schemas.openxmlformats.org/drawingml/2006/diagram" xmlns:o="urn:schemas-microsoft-com:office:office" xmlns:v="urn:schemas-microsoft-com:vml" xmlns:pvml="urn:schemas-microsoft-com:office:powerpoint" xmlns:com="http://schemas.openxmlformats.org/drawingml/2006/compatibility" xmlns:p14="http://schemas.microsoft.com/office/powerpoint/2010/main" xmlns:p15="http://schemas.microsoft.com/office/powerpoint/2012/main" xmlns:ahyp="http://schemas.microsoft.com/office/drawing/2018/hyperlinkcolor">
   <p:cSld>
     <p:spTree>
@@ -7088,7 +7092,7 @@
 </p:sld>
 </file>
 
-<file path=ppt/slides/slide12.xml><?xml version="1.0" encoding="utf-8"?>
+<file path=ppt\slides\slide12.xml><?xml version="1.0" encoding="utf-8"?>
 <p:sld xmlns:a="http://schemas.openxmlformats.org/drawingml/2006/main" xmlns:r="http://schemas.openxmlformats.org/officeDocument/2006/relationships" xmlns:mc="http://schemas.openxmlformats.org/markup-compatibility/2006" xmlns:mv="urn:schemas-microsoft-com:mac:vml" xmlns:p="http://schemas.openxmlformats.org/presentationml/2006/main" xmlns:c="http://schemas.openxmlformats.org/drawingml/2006/chart" xmlns:dgm="http://schemas.openxmlformats.org/drawingml/2006/diagram" xmlns:o="urn:schemas-microsoft-com:office:office" xmlns:v="urn:schemas-microsoft-com:vml" xmlns:pvml="urn:schemas-microsoft-com:office:powerpoint" xmlns:com="http://schemas.openxmlformats.org/drawingml/2006/compatibility" xmlns:p14="http://schemas.microsoft.com/office/powerpoint/2010/main" xmlns:p15="http://schemas.microsoft.com/office/powerpoint/2012/main" xmlns:ahyp="http://schemas.microsoft.com/office/drawing/2018/hyperlinkcolor">
   <p:cSld>
     <p:spTree>
@@ -7366,7 +7370,7 @@
 </p:sld>
 </file>
 
-<file path=ppt/slides/slide13.xml><?xml version="1.0" encoding="utf-8"?>
+<file path=ppt\slides\slide13.xml><?xml version="1.0" encoding="utf-8"?>
 <p:sld xmlns:a="http://schemas.openxmlformats.org/drawingml/2006/main" xmlns:r="http://schemas.openxmlformats.org/officeDocument/2006/relationships" xmlns:mc="http://schemas.openxmlformats.org/markup-compatibility/2006" xmlns:mv="urn:schemas-microsoft-com:mac:vml" xmlns:p="http://schemas.openxmlformats.org/presentationml/2006/main" xmlns:c="http://schemas.openxmlformats.org/drawingml/2006/chart" xmlns:dgm="http://schemas.openxmlformats.org/drawingml/2006/diagram" xmlns:o="urn:schemas-microsoft-com:office:office" xmlns:v="urn:schemas-microsoft-com:vml" xmlns:pvml="urn:schemas-microsoft-com:office:powerpoint" xmlns:com="http://schemas.openxmlformats.org/drawingml/2006/compatibility" xmlns:p14="http://schemas.microsoft.com/office/powerpoint/2010/main" xmlns:p15="http://schemas.microsoft.com/office/powerpoint/2012/main" xmlns:ahyp="http://schemas.microsoft.com/office/drawing/2018/hyperlinkcolor">
   <p:cSld>
     <p:spTree>
@@ -7454,7 +7458,7 @@
                 <a:spcPts val="0"/>
               </a:spcAft>
               <a:buSzPts val="1900"/>
-              <a:buChar char="●"/>
+              <a:buChar char="â—"/>
             </a:pPr>
             <a:r>
               <a:rPr lang="en-GB" sz="1900"/>
@@ -7471,7 +7475,7 @@
                 <a:spcPts val="0"/>
               </a:spcAft>
               <a:buSzPts val="1900"/>
-              <a:buChar char="●"/>
+              <a:buChar char="â—"/>
             </a:pPr>
             <a:r>
               <a:rPr lang="en-GB" sz="1900"/>
@@ -7488,7 +7492,7 @@
                 <a:spcPts val="0"/>
               </a:spcAft>
               <a:buSzPts val="1900"/>
-              <a:buChar char="●"/>
+              <a:buChar char="â—"/>
             </a:pPr>
             <a:r>
               <a:rPr lang="en-GB" sz="1900"/>
@@ -7505,7 +7509,7 @@
                 <a:spcPts val="0"/>
               </a:spcAft>
               <a:buSzPts val="1800"/>
-              <a:buChar char="●"/>
+              <a:buChar char="â—"/>
             </a:pPr>
             <a:r>
               <a:rPr lang="en-GB" sz="1900"/>
@@ -7524,7 +7528,7 @@
                   </a:extLst>
                 </a:hlinkClick>
               </a:rPr>
-              <a:t>Vatshayan007@gmail.com</a:t>
+              <a:t>toshi007@gmail.com</a:t>
             </a:r>
             <a:r>
               <a:rPr lang="en-GB" sz="1900"/>
@@ -7572,7 +7576,7 @@
                   <a:srgbClr val="FF0000"/>
                 </a:solidFill>
               </a:rPr>
-              <a:t>Shivam Vatshayan</a:t>
+              <a:t>Shivam toshi</a:t>
             </a:r>
             <a:endParaRPr sz="2300">
               <a:solidFill>
@@ -7646,7 +7650,7 @@
 </p:sld>
 </file>
 
-<file path=ppt/slides/slide2.xml><?xml version="1.0" encoding="utf-8"?>
+<file path=ppt\slides\slide2.xml><?xml version="1.0" encoding="utf-8"?>
 <p:sld xmlns:a="http://schemas.openxmlformats.org/drawingml/2006/main" xmlns:r="http://schemas.openxmlformats.org/officeDocument/2006/relationships" xmlns:mc="http://schemas.openxmlformats.org/markup-compatibility/2006" xmlns:mv="urn:schemas-microsoft-com:mac:vml" xmlns:p="http://schemas.openxmlformats.org/presentationml/2006/main" xmlns:c="http://schemas.openxmlformats.org/drawingml/2006/chart" xmlns:dgm="http://schemas.openxmlformats.org/drawingml/2006/diagram" xmlns:o="urn:schemas-microsoft-com:office:office" xmlns:v="urn:schemas-microsoft-com:vml" xmlns:pvml="urn:schemas-microsoft-com:office:powerpoint" xmlns:com="http://schemas.openxmlformats.org/drawingml/2006/compatibility" xmlns:p14="http://schemas.microsoft.com/office/powerpoint/2010/main" xmlns:p15="http://schemas.microsoft.com/office/powerpoint/2012/main" xmlns:ahyp="http://schemas.microsoft.com/office/drawing/2018/hyperlinkcolor">
   <p:cSld>
     <p:spTree>
@@ -7959,7 +7963,7 @@
 </p:sld>
 </file>
 
-<file path=ppt/slides/slide3.xml><?xml version="1.0" encoding="utf-8"?>
+<file path=ppt\slides\slide3.xml><?xml version="1.0" encoding="utf-8"?>
 <p:sld xmlns:a="http://schemas.openxmlformats.org/drawingml/2006/main" xmlns:r="http://schemas.openxmlformats.org/officeDocument/2006/relationships" xmlns:mc="http://schemas.openxmlformats.org/markup-compatibility/2006" xmlns:mv="urn:schemas-microsoft-com:mac:vml" xmlns:p="http://schemas.openxmlformats.org/presentationml/2006/main" xmlns:c="http://schemas.openxmlformats.org/drawingml/2006/chart" xmlns:dgm="http://schemas.openxmlformats.org/drawingml/2006/diagram" xmlns:o="urn:schemas-microsoft-com:office:office" xmlns:v="urn:schemas-microsoft-com:vml" xmlns:pvml="urn:schemas-microsoft-com:office:powerpoint" xmlns:com="http://schemas.openxmlformats.org/drawingml/2006/compatibility" xmlns:p14="http://schemas.microsoft.com/office/powerpoint/2010/main" xmlns:p15="http://schemas.microsoft.com/office/powerpoint/2012/main" xmlns:ahyp="http://schemas.microsoft.com/office/drawing/2018/hyperlinkcolor">
   <p:cSld>
     <p:spTree>
@@ -8248,7 +8252,7 @@
 </p:sld>
 </file>
 
-<file path=ppt/slides/slide4.xml><?xml version="1.0" encoding="utf-8"?>
+<file path=ppt\slides\slide4.xml><?xml version="1.0" encoding="utf-8"?>
 <p:sld xmlns:a="http://schemas.openxmlformats.org/drawingml/2006/main" xmlns:r="http://schemas.openxmlformats.org/officeDocument/2006/relationships" xmlns:mc="http://schemas.openxmlformats.org/markup-compatibility/2006" xmlns:mv="urn:schemas-microsoft-com:mac:vml" xmlns:p="http://schemas.openxmlformats.org/presentationml/2006/main" xmlns:c="http://schemas.openxmlformats.org/drawingml/2006/chart" xmlns:dgm="http://schemas.openxmlformats.org/drawingml/2006/diagram" xmlns:o="urn:schemas-microsoft-com:office:office" xmlns:v="urn:schemas-microsoft-com:vml" xmlns:pvml="urn:schemas-microsoft-com:office:powerpoint" xmlns:com="http://schemas.openxmlformats.org/drawingml/2006/compatibility" xmlns:p14="http://schemas.microsoft.com/office/powerpoint/2010/main" xmlns:p15="http://schemas.microsoft.com/office/powerpoint/2012/main" xmlns:ahyp="http://schemas.microsoft.com/office/drawing/2018/hyperlinkcolor">
   <p:cSld>
     <p:spTree>
@@ -8380,7 +8384,7 @@
 </p:sld>
 </file>
 
-<file path=ppt/slides/slide5.xml><?xml version="1.0" encoding="utf-8"?>
+<file path=ppt\slides\slide5.xml><?xml version="1.0" encoding="utf-8"?>
 <p:sld xmlns:a="http://schemas.openxmlformats.org/drawingml/2006/main" xmlns:r="http://schemas.openxmlformats.org/officeDocument/2006/relationships" xmlns:mc="http://schemas.openxmlformats.org/markup-compatibility/2006" xmlns:mv="urn:schemas-microsoft-com:mac:vml" xmlns:p="http://schemas.openxmlformats.org/presentationml/2006/main" xmlns:c="http://schemas.openxmlformats.org/drawingml/2006/chart" xmlns:dgm="http://schemas.openxmlformats.org/drawingml/2006/diagram" xmlns:o="urn:schemas-microsoft-com:office:office" xmlns:v="urn:schemas-microsoft-com:vml" xmlns:pvml="urn:schemas-microsoft-com:office:powerpoint" xmlns:com="http://schemas.openxmlformats.org/drawingml/2006/compatibility" xmlns:p14="http://schemas.microsoft.com/office/powerpoint/2010/main" xmlns:p15="http://schemas.microsoft.com/office/powerpoint/2012/main" xmlns:ahyp="http://schemas.microsoft.com/office/drawing/2018/hyperlinkcolor">
   <p:cSld>
     <p:spTree>
@@ -8567,7 +8571,7 @@
 </p:sld>
 </file>
 
-<file path=ppt/slides/slide6.xml><?xml version="1.0" encoding="utf-8"?>
+<file path=ppt\slides\slide6.xml><?xml version="1.0" encoding="utf-8"?>
 <p:sld xmlns:a="http://schemas.openxmlformats.org/drawingml/2006/main" xmlns:r="http://schemas.openxmlformats.org/officeDocument/2006/relationships" xmlns:mc="http://schemas.openxmlformats.org/markup-compatibility/2006" xmlns:mv="urn:schemas-microsoft-com:mac:vml" xmlns:p="http://schemas.openxmlformats.org/presentationml/2006/main" xmlns:c="http://schemas.openxmlformats.org/drawingml/2006/chart" xmlns:dgm="http://schemas.openxmlformats.org/drawingml/2006/diagram" xmlns:o="urn:schemas-microsoft-com:office:office" xmlns:v="urn:schemas-microsoft-com:vml" xmlns:pvml="urn:schemas-microsoft-com:office:powerpoint" xmlns:com="http://schemas.openxmlformats.org/drawingml/2006/compatibility" xmlns:p14="http://schemas.microsoft.com/office/powerpoint/2010/main" xmlns:p15="http://schemas.microsoft.com/office/powerpoint/2012/main" xmlns:ahyp="http://schemas.microsoft.com/office/drawing/2018/hyperlinkcolor">
   <p:cSld>
     <p:spTree>
@@ -8906,7 +8910,7 @@
 </p:sld>
 </file>
 
-<file path=ppt/slides/slide7.xml><?xml version="1.0" encoding="utf-8"?>
+<file path=ppt\slides\slide7.xml><?xml version="1.0" encoding="utf-8"?>
 <p:sld xmlns:a="http://schemas.openxmlformats.org/drawingml/2006/main" xmlns:r="http://schemas.openxmlformats.org/officeDocument/2006/relationships" xmlns:mc="http://schemas.openxmlformats.org/markup-compatibility/2006" xmlns:mv="urn:schemas-microsoft-com:mac:vml" xmlns:p="http://schemas.openxmlformats.org/presentationml/2006/main" xmlns:c="http://schemas.openxmlformats.org/drawingml/2006/chart" xmlns:dgm="http://schemas.openxmlformats.org/drawingml/2006/diagram" xmlns:o="urn:schemas-microsoft-com:office:office" xmlns:v="urn:schemas-microsoft-com:vml" xmlns:pvml="urn:schemas-microsoft-com:office:powerpoint" xmlns:com="http://schemas.openxmlformats.org/drawingml/2006/compatibility" xmlns:p14="http://schemas.microsoft.com/office/powerpoint/2010/main" xmlns:p15="http://schemas.microsoft.com/office/powerpoint/2012/main" xmlns:ahyp="http://schemas.microsoft.com/office/drawing/2018/hyperlinkcolor">
   <p:cSld>
     <p:spTree>
@@ -9144,7 +9148,7 @@
 </p:sld>
 </file>
 
-<file path=ppt/slides/slide8.xml><?xml version="1.0" encoding="utf-8"?>
+<file path=ppt\slides\slide8.xml><?xml version="1.0" encoding="utf-8"?>
 <p:sld xmlns:a="http://schemas.openxmlformats.org/drawingml/2006/main" xmlns:r="http://schemas.openxmlformats.org/officeDocument/2006/relationships" xmlns:mc="http://schemas.openxmlformats.org/markup-compatibility/2006" xmlns:mv="urn:schemas-microsoft-com:mac:vml" xmlns:p="http://schemas.openxmlformats.org/presentationml/2006/main" xmlns:c="http://schemas.openxmlformats.org/drawingml/2006/chart" xmlns:dgm="http://schemas.openxmlformats.org/drawingml/2006/diagram" xmlns:o="urn:schemas-microsoft-com:office:office" xmlns:v="urn:schemas-microsoft-com:vml" xmlns:pvml="urn:schemas-microsoft-com:office:powerpoint" xmlns:com="http://schemas.openxmlformats.org/drawingml/2006/compatibility" xmlns:p14="http://schemas.microsoft.com/office/powerpoint/2010/main" xmlns:p15="http://schemas.microsoft.com/office/powerpoint/2012/main" xmlns:ahyp="http://schemas.microsoft.com/office/drawing/2018/hyperlinkcolor">
   <p:cSld>
     <p:spTree>
@@ -9497,7 +9501,7 @@
 </p:sld>
 </file>
 
-<file path=ppt/slides/slide9.xml><?xml version="1.0" encoding="utf-8"?>
+<file path=ppt\slides\slide9.xml><?xml version="1.0" encoding="utf-8"?>
 <p:sld xmlns:a="http://schemas.openxmlformats.org/drawingml/2006/main" xmlns:r="http://schemas.openxmlformats.org/officeDocument/2006/relationships" xmlns:mc="http://schemas.openxmlformats.org/markup-compatibility/2006" xmlns:mv="urn:schemas-microsoft-com:mac:vml" xmlns:p="http://schemas.openxmlformats.org/presentationml/2006/main" xmlns:c="http://schemas.openxmlformats.org/drawingml/2006/chart" xmlns:dgm="http://schemas.openxmlformats.org/drawingml/2006/diagram" xmlns:o="urn:schemas-microsoft-com:office:office" xmlns:v="urn:schemas-microsoft-com:vml" xmlns:pvml="urn:schemas-microsoft-com:office:powerpoint" xmlns:com="http://schemas.openxmlformats.org/drawingml/2006/compatibility" xmlns:p14="http://schemas.microsoft.com/office/powerpoint/2010/main" xmlns:p15="http://schemas.microsoft.com/office/powerpoint/2012/main" xmlns:ahyp="http://schemas.microsoft.com/office/drawing/2018/hyperlinkcolor">
   <p:cSld>
     <p:spTree>
@@ -9815,7 +9819,7 @@
 </p:sld>
 </file>
 
-<file path=ppt/theme/theme1.xml><?xml version="1.0" encoding="utf-8"?>
+<file path=ppt\theme\theme1.xml><?xml version="1.0" encoding="utf-8"?>
 <a:theme xmlns:a="http://schemas.openxmlformats.org/drawingml/2006/main" xmlns:r="http://schemas.openxmlformats.org/officeDocument/2006/relationships" name="Simple Light">
   <a:themeElements>
     <a:clrScheme name="Simple Light">
@@ -10094,7 +10098,7 @@
 </a:theme>
 </file>
 
-<file path=ppt/theme/theme2.xml><?xml version="1.0" encoding="utf-8"?>
+<file path=ppt\theme\theme2.xml><?xml version="1.0" encoding="utf-8"?>
 <a:theme xmlns:a="http://schemas.openxmlformats.org/drawingml/2006/main" xmlns:r="http://schemas.openxmlformats.org/officeDocument/2006/relationships">
   <a:themeElements>
     <a:clrScheme name="Default">
@@ -10371,4 +10375,24 @@
     </a:fmtScheme>
   </a:themeElements>
 </a:theme>
+</file>
+
+<file path=ppt\viewProps.xml><?xml version="1.0" encoding="utf-8"?>
+<p:viewPr xmlns:a="http://schemas.openxmlformats.org/drawingml/2006/main" xmlns:r="http://schemas.openxmlformats.org/officeDocument/2006/relationships" xmlns:mc="http://schemas.openxmlformats.org/markup-compatibility/2006" xmlns:mv="urn:schemas-microsoft-com:mac:vml" xmlns:p="http://schemas.openxmlformats.org/presentationml/2006/main" xmlns:c="http://schemas.openxmlformats.org/drawingml/2006/chart" xmlns:dgm="http://schemas.openxmlformats.org/drawingml/2006/diagram" xmlns:o="urn:schemas-microsoft-com:office:office" xmlns:v="urn:schemas-microsoft-com:vml" xmlns:pvml="urn:schemas-microsoft-com:office:powerpoint" xmlns:com="http://schemas.openxmlformats.org/drawingml/2006/compatibility" xmlns:p14="http://schemas.microsoft.com/office/powerpoint/2010/main" xmlns:p15="http://schemas.microsoft.com/office/powerpoint/2012/main" xmlns:ahyp="http://schemas.microsoft.com/office/drawing/2018/hyperlinkcolor" showComments="0">
+  <p:slideViewPr>
+    <p:cSldViewPr snapToGrid="0">
+      <p:cViewPr varScale="1">
+        <p:scale>
+          <a:sx n="100" d="100"/>
+          <a:sy n="100" d="100"/>
+        </p:scale>
+        <p:origin x="0" y="0"/>
+      </p:cViewPr>
+      <p:guideLst>
+        <p:guide pos="1620" orient="horz"/>
+        <p:guide pos="2880"/>
+      </p:guideLst>
+    </p:cSldViewPr>
+  </p:slideViewPr>
+</p:viewPr>
 </file>
</xml_diff>